<commit_message>
feat(presentation): show agent and durability architecture
</commit_message>
<xml_diff>
--- a/docs/presentation/batchhelm-ai-hackathon-deck.pptx
+++ b/docs/presentation/batchhelm-ai-hackathon-deck.pptx
@@ -4564,7 +4564,7 @@
           <p:cNvPr id="4" name="Rounded Rectangle 3">
             <a:extLst>
               <a:ext uri="{FF2B5EF4-FFF2-40B4-BE49-F238E27FC236}">
-                <a16:creationId xmlns:a16="http://schemas.microsoft.com/office/drawing/2014/main" id="{1FA28C1A-DE4E-4383-A352-07DEA7222B68}"/>
+                <a16:creationId xmlns:a16="http://schemas.microsoft.com/office/drawing/2014/main" id="{5E9C2518-2735-404A-8D1B-F550CF62E5B8}"/>
               </a:ext>
             </a:extLst>
           </p:cNvPr>
@@ -5138,7 +5138,7 @@
           <p:cNvPr id="4" name="Rounded Rectangle 3">
             <a:extLst>
               <a:ext uri="{FF2B5EF4-FFF2-40B4-BE49-F238E27FC236}">
-                <a16:creationId xmlns:a16="http://schemas.microsoft.com/office/drawing/2014/main" id="{2B490E8F-00CF-45F6-B973-6DA0619C4643}"/>
+                <a16:creationId xmlns:a16="http://schemas.microsoft.com/office/drawing/2014/main" id="{78E3EF89-EEAF-4F60-A1B1-4B4483142F6B}"/>
               </a:ext>
             </a:extLst>
           </p:cNvPr>
@@ -5180,7 +5180,7 @@
           <p:cNvPr id="5" name="Rectangle 4">
             <a:extLst>
               <a:ext uri="{FF2B5EF4-FFF2-40B4-BE49-F238E27FC236}">
-                <a16:creationId xmlns:a16="http://schemas.microsoft.com/office/drawing/2014/main" id="{888064A8-12A9-45DF-A2B4-A349722D436B}"/>
+                <a16:creationId xmlns:a16="http://schemas.microsoft.com/office/drawing/2014/main" id="{32F7A7FA-E038-471F-8626-48B19F8B4F5C}"/>
               </a:ext>
             </a:extLst>
           </p:cNvPr>
@@ -5242,7 +5242,7 @@
           <p:cNvPr id="6" name="Rounded Rectangle 5">
             <a:extLst>
               <a:ext uri="{FF2B5EF4-FFF2-40B4-BE49-F238E27FC236}">
-                <a16:creationId xmlns:a16="http://schemas.microsoft.com/office/drawing/2014/main" id="{BE193801-2704-484B-8D49-0049E7BCE4AC}"/>
+                <a16:creationId xmlns:a16="http://schemas.microsoft.com/office/drawing/2014/main" id="{D5E98621-BDEE-428B-B5ED-F116E5DBBDAA}"/>
               </a:ext>
             </a:extLst>
           </p:cNvPr>
@@ -5308,7 +5308,7 @@
           <p:cNvPr id="8" name="Rounded Rectangle 7">
             <a:extLst>
               <a:ext uri="{FF2B5EF4-FFF2-40B4-BE49-F238E27FC236}">
-                <a16:creationId xmlns:a16="http://schemas.microsoft.com/office/drawing/2014/main" id="{9783372D-E10D-4C3F-B63E-6A027688112D}"/>
+                <a16:creationId xmlns:a16="http://schemas.microsoft.com/office/drawing/2014/main" id="{63DDFC06-13AF-4E9A-B444-8A604638BFF5}"/>
               </a:ext>
             </a:extLst>
           </p:cNvPr>
@@ -5377,7 +5377,7 @@
           <p:cNvPr id="10" name="Rectangle 9">
             <a:extLst>
               <a:ext uri="{FF2B5EF4-FFF2-40B4-BE49-F238E27FC236}">
-                <a16:creationId xmlns:a16="http://schemas.microsoft.com/office/drawing/2014/main" id="{2148A1BA-B2D9-4B9A-82C7-4D4CD3C411EA}"/>
+                <a16:creationId xmlns:a16="http://schemas.microsoft.com/office/drawing/2014/main" id="{50D66590-44F1-4708-8617-F8CEC4BC1F12}"/>
               </a:ext>
             </a:extLst>
           </p:cNvPr>
@@ -5806,7 +5806,7 @@
           <p:cNvPr id="4" name="Rectangle 3">
             <a:extLst>
               <a:ext uri="{FF2B5EF4-FFF2-40B4-BE49-F238E27FC236}">
-                <a16:creationId xmlns:a16="http://schemas.microsoft.com/office/drawing/2014/main" id="{1CF70062-3F71-4744-A0CB-D0CB43B2DAFE}"/>
+                <a16:creationId xmlns:a16="http://schemas.microsoft.com/office/drawing/2014/main" id="{CFC7DA05-A0A6-43F1-B11C-649CC014A181}"/>
               </a:ext>
             </a:extLst>
           </p:cNvPr>
@@ -5879,7 +5879,7 @@
           <p:cNvPr id="5" name="Rectangle 4">
             <a:extLst>
               <a:ext uri="{FF2B5EF4-FFF2-40B4-BE49-F238E27FC236}">
-                <a16:creationId xmlns:a16="http://schemas.microsoft.com/office/drawing/2014/main" id="{E49406E0-FB77-40D0-92AF-9C7ECDDB0F65}"/>
+                <a16:creationId xmlns:a16="http://schemas.microsoft.com/office/drawing/2014/main" id="{44638042-81DC-41E5-9A67-3D389E2985F3}"/>
               </a:ext>
             </a:extLst>
           </p:cNvPr>
@@ -5919,7 +5919,7 @@
           <p:cNvPr id="6" name="Rectangle 5">
             <a:extLst>
               <a:ext uri="{FF2B5EF4-FFF2-40B4-BE49-F238E27FC236}">
-                <a16:creationId xmlns:a16="http://schemas.microsoft.com/office/drawing/2014/main" id="{CD7E3841-2DC3-41D2-9CB3-17452DAD3E8E}"/>
+                <a16:creationId xmlns:a16="http://schemas.microsoft.com/office/drawing/2014/main" id="{80E8BE82-F1AB-47FF-908A-88220C0A9BAB}"/>
               </a:ext>
             </a:extLst>
           </p:cNvPr>
@@ -5992,7 +5992,7 @@
           <p:cNvPr id="7" name="Rectangle 6">
             <a:extLst>
               <a:ext uri="{FF2B5EF4-FFF2-40B4-BE49-F238E27FC236}">
-                <a16:creationId xmlns:a16="http://schemas.microsoft.com/office/drawing/2014/main" id="{62DAB98C-AF8E-42BE-8A72-D113CBCF80B9}"/>
+                <a16:creationId xmlns:a16="http://schemas.microsoft.com/office/drawing/2014/main" id="{6DEA5E17-1DED-4E99-A8B9-1672AD49990E}"/>
               </a:ext>
             </a:extLst>
           </p:cNvPr>
@@ -6032,7 +6032,7 @@
           <p:cNvPr id="8" name="Rectangle 7">
             <a:extLst>
               <a:ext uri="{FF2B5EF4-FFF2-40B4-BE49-F238E27FC236}">
-                <a16:creationId xmlns:a16="http://schemas.microsoft.com/office/drawing/2014/main" id="{F7AD2D69-77BC-4EDA-8F89-18DFD7E13089}"/>
+                <a16:creationId xmlns:a16="http://schemas.microsoft.com/office/drawing/2014/main" id="{E99D4AB8-3576-4BF6-87F2-74361EA1D8F7}"/>
               </a:ext>
             </a:extLst>
           </p:cNvPr>
@@ -6105,7 +6105,7 @@
           <p:cNvPr id="9" name="Rounded Rectangle 8">
             <a:extLst>
               <a:ext uri="{FF2B5EF4-FFF2-40B4-BE49-F238E27FC236}">
-                <a16:creationId xmlns:a16="http://schemas.microsoft.com/office/drawing/2014/main" id="{13F33523-382D-4588-8EDC-A527AFF4FBB9}"/>
+                <a16:creationId xmlns:a16="http://schemas.microsoft.com/office/drawing/2014/main" id="{9BAA7DC2-6A53-4B71-86D4-686B68C048A0}"/>
               </a:ext>
             </a:extLst>
           </p:cNvPr>
@@ -6171,7 +6171,7 @@
           <p:cNvPr id="11" name="Rounded Rectangle 10">
             <a:extLst>
               <a:ext uri="{FF2B5EF4-FFF2-40B4-BE49-F238E27FC236}">
-                <a16:creationId xmlns:a16="http://schemas.microsoft.com/office/drawing/2014/main" id="{11FD2D1A-7507-437C-8997-0926BEB0417B}"/>
+                <a16:creationId xmlns:a16="http://schemas.microsoft.com/office/drawing/2014/main" id="{77FE3062-DBEF-436C-B97A-C14E87C5206B}"/>
               </a:ext>
             </a:extLst>
           </p:cNvPr>
@@ -6237,7 +6237,7 @@
           <p:cNvPr id="13" name="Rounded Rectangle 12">
             <a:extLst>
               <a:ext uri="{FF2B5EF4-FFF2-40B4-BE49-F238E27FC236}">
-                <a16:creationId xmlns:a16="http://schemas.microsoft.com/office/drawing/2014/main" id="{B5D0DEFD-8056-4060-A23E-DCDEC2B6FEBC}"/>
+                <a16:creationId xmlns:a16="http://schemas.microsoft.com/office/drawing/2014/main" id="{AA875BFC-F62C-4C2E-A408-06B56D7BE6AD}"/>
               </a:ext>
             </a:extLst>
           </p:cNvPr>
@@ -6279,7 +6279,7 @@
           <p:cNvPr id="14" name="Rectangle 13">
             <a:extLst>
               <a:ext uri="{FF2B5EF4-FFF2-40B4-BE49-F238E27FC236}">
-                <a16:creationId xmlns:a16="http://schemas.microsoft.com/office/drawing/2014/main" id="{34F8F8FC-510E-41D3-BEA3-6A6CAC39DAD5}"/>
+                <a16:creationId xmlns:a16="http://schemas.microsoft.com/office/drawing/2014/main" id="{E9AB5BA9-E7A0-44B8-8CF9-D684A23579E2}"/>
               </a:ext>
             </a:extLst>
           </p:cNvPr>
@@ -6763,7 +6763,7 @@
           <p:cNvPr id="4" name="Rounded Rectangle 3">
             <a:extLst>
               <a:ext uri="{FF2B5EF4-FFF2-40B4-BE49-F238E27FC236}">
-                <a16:creationId xmlns:a16="http://schemas.microsoft.com/office/drawing/2014/main" id="{7F73BC63-2B07-4DC0-AFAB-7BD27815B0B8}"/>
+                <a16:creationId xmlns:a16="http://schemas.microsoft.com/office/drawing/2014/main" id="{0917426A-F966-42C6-9C13-11694049DB53}"/>
               </a:ext>
             </a:extLst>
           </p:cNvPr>
@@ -6829,7 +6829,7 @@
           <p:cNvPr id="6" name="Rounded Rectangle 5">
             <a:extLst>
               <a:ext uri="{FF2B5EF4-FFF2-40B4-BE49-F238E27FC236}">
-                <a16:creationId xmlns:a16="http://schemas.microsoft.com/office/drawing/2014/main" id="{B3D48685-D400-4977-AB16-250FE05F7A9D}"/>
+                <a16:creationId xmlns:a16="http://schemas.microsoft.com/office/drawing/2014/main" id="{993A5729-2DBC-4C05-8873-26C4974EBDCB}"/>
               </a:ext>
             </a:extLst>
           </p:cNvPr>
@@ -6871,7 +6871,7 @@
           <p:cNvPr id="7" name="Rectangle 6">
             <a:extLst>
               <a:ext uri="{FF2B5EF4-FFF2-40B4-BE49-F238E27FC236}">
-                <a16:creationId xmlns:a16="http://schemas.microsoft.com/office/drawing/2014/main" id="{7C23BA79-8918-41B5-B9CF-FC8FD5167DB3}"/>
+                <a16:creationId xmlns:a16="http://schemas.microsoft.com/office/drawing/2014/main" id="{1ECE6D09-8698-4331-89F3-ED8BBF53AEFE}"/>
               </a:ext>
             </a:extLst>
           </p:cNvPr>
@@ -6933,7 +6933,7 @@
           <p:cNvPr id="8" name="Rounded Rectangle 7">
             <a:extLst>
               <a:ext uri="{FF2B5EF4-FFF2-40B4-BE49-F238E27FC236}">
-                <a16:creationId xmlns:a16="http://schemas.microsoft.com/office/drawing/2014/main" id="{43CA64C9-ECC5-4F61-978A-4976A87719A2}"/>
+                <a16:creationId xmlns:a16="http://schemas.microsoft.com/office/drawing/2014/main" id="{08BC1510-2D23-40C2-9A8C-45F903658CC6}"/>
               </a:ext>
             </a:extLst>
           </p:cNvPr>
@@ -6975,7 +6975,7 @@
           <p:cNvPr id="9" name="Rectangle 8">
             <a:extLst>
               <a:ext uri="{FF2B5EF4-FFF2-40B4-BE49-F238E27FC236}">
-                <a16:creationId xmlns:a16="http://schemas.microsoft.com/office/drawing/2014/main" id="{C5C8CA68-C7FA-45DB-9334-5057F5A174FA}"/>
+                <a16:creationId xmlns:a16="http://schemas.microsoft.com/office/drawing/2014/main" id="{A0CD4B93-2C96-42C7-89EF-2610DF10808D}"/>
               </a:ext>
             </a:extLst>
           </p:cNvPr>
@@ -7064,7 +7064,7 @@
           <p:cNvPr id="10" name="Rectangle 9">
             <a:extLst>
               <a:ext uri="{FF2B5EF4-FFF2-40B4-BE49-F238E27FC236}">
-                <a16:creationId xmlns:a16="http://schemas.microsoft.com/office/drawing/2014/main" id="{3F76FC5B-C359-490C-9465-0A15A9D37864}"/>
+                <a16:creationId xmlns:a16="http://schemas.microsoft.com/office/drawing/2014/main" id="{925F015E-3C71-4651-9F92-4739E6B50B04}"/>
               </a:ext>
             </a:extLst>
           </p:cNvPr>
@@ -7104,7 +7104,7 @@
           <p:cNvPr id="11" name="Rectangle 10">
             <a:extLst>
               <a:ext uri="{FF2B5EF4-FFF2-40B4-BE49-F238E27FC236}">
-                <a16:creationId xmlns:a16="http://schemas.microsoft.com/office/drawing/2014/main" id="{55A326A9-1925-4416-B3CC-BB4B52C1BB45}"/>
+                <a16:creationId xmlns:a16="http://schemas.microsoft.com/office/drawing/2014/main" id="{B2CE3884-1CAE-4A20-BF01-B79DDD309CC8}"/>
               </a:ext>
             </a:extLst>
           </p:cNvPr>
@@ -7177,7 +7177,7 @@
           <p:cNvPr id="12" name="Rectangle 11">
             <a:extLst>
               <a:ext uri="{FF2B5EF4-FFF2-40B4-BE49-F238E27FC236}">
-                <a16:creationId xmlns:a16="http://schemas.microsoft.com/office/drawing/2014/main" id="{3EF8F6BA-A4C1-48A9-9F8F-4170C38CB8F6}"/>
+                <a16:creationId xmlns:a16="http://schemas.microsoft.com/office/drawing/2014/main" id="{A20F7DEE-372C-4C20-85AC-F449420C6317}"/>
               </a:ext>
             </a:extLst>
           </p:cNvPr>
@@ -7217,7 +7217,7 @@
           <p:cNvPr id="13" name="Rectangle 12">
             <a:extLst>
               <a:ext uri="{FF2B5EF4-FFF2-40B4-BE49-F238E27FC236}">
-                <a16:creationId xmlns:a16="http://schemas.microsoft.com/office/drawing/2014/main" id="{76AEFC66-9AD9-4079-A6DE-EA10BB2BBA4B}"/>
+                <a16:creationId xmlns:a16="http://schemas.microsoft.com/office/drawing/2014/main" id="{9745E85A-CD3D-413F-98F5-11D4AC34A478}"/>
               </a:ext>
             </a:extLst>
           </p:cNvPr>
@@ -7301,6 +7301,14 @@
 <file path=ppt/slides/slide5.xml><?xml version="1.0" encoding="utf-8"?>
 <p:sld xmlns:a="http://schemas.openxmlformats.org/drawingml/2006/main" xmlns:r="http://schemas.openxmlformats.org/officeDocument/2006/relationships" xmlns:p="http://schemas.openxmlformats.org/presentationml/2006/main">
   <p:cSld>
+    <p:bg>
+      <p:bgPr>
+        <a:solidFill>
+          <a:srgbClr val="F8FBFA"/>
+        </a:solidFill>
+        <a:effectLst/>
+      </p:bgPr>
+    </p:bg>
     <p:spTree>
       <p:nvGrpSpPr>
         <p:cNvPr id="1" name=""/>
@@ -7331,21 +7339,42 @@
             <p:ph type="title"/>
           </p:nvPr>
         </p:nvSpPr>
-        <p:spPr/>
-        <p:txBody>
-          <a:bodyPr/>
-          <a:lstStyle/>
-          <a:p>
-            <a:pPr>
-              <a:buNone/>
-              <a:defRPr sz="3200">
-                <a:solidFill>
-                  <a:srgbClr val="1F6FEB"/>
-                </a:solidFill>
+        <p:spPr>
+          <a:xfrm>
+            <a:off x="609600" y="419100"/>
+            <a:ext cx="10934700" cy="781050"/>
+          </a:xfrm>
+        </p:spPr>
+        <p:txBody>
+          <a:bodyPr wrap="square" lIns="0" tIns="0" rIns="0" bIns="0" anchor="ctr">
+            <a:normAutofit/>
+          </a:bodyPr>
+          <a:lstStyle/>
+          <a:p>
+            <a:pPr marL="0" indent="0" algn="l">
+              <a:spcAft>
+                <a:spcPts val="0"/>
+              </a:spcAft>
+              <a:buNone/>
+              <a:defRPr sz="3600" b="1">
+                <a:solidFill>
+                  <a:srgbClr val="132925"/>
+                </a:solidFill>
+                <a:latin typeface="Aptos Display"/>
+                <a:ea typeface="Aptos Display"/>
+                <a:cs typeface="Aptos Display"/>
               </a:defRPr>
             </a:pPr>
             <a:r>
-              <a:t>Qwen Cloud Integration</a:t>
+              <a:rPr sz="3600" b="1" i="0">
+                <a:solidFill>
+                  <a:srgbClr val="132925"/>
+                </a:solidFill>
+                <a:latin typeface="Aptos Display"/>
+                <a:ea typeface="Aptos Display"/>
+                <a:cs typeface="Aptos Display"/>
+              </a:rPr>
+              <a:t>Qwen handles the uncertain work</a:t>
             </a:r>
           </a:p>
         </p:txBody>
@@ -7366,60 +7395,1114 @@
             <p:ph idx="1"/>
           </p:nvPr>
         </p:nvSpPr>
-        <p:spPr/>
-        <p:txBody>
-          <a:bodyPr wrap="square"/>
-          <a:lstStyle/>
-          <a:p>
-            <a:pPr>
-              <a:buNone/>
-            </a:pPr>
-            <a:r>
-              <a:rPr sz="1800">
-                <a:solidFill>
-                  <a:srgbClr val="222222"/>
-                </a:solidFill>
-              </a:rPr>
-              <a:t>Calls Qwen Cloud through Alibaba Cloud Model Studio's OpenAI-compatible chat endpoint — qwen-plus for text, qwen-vl-plus for shelf-photo vision.</a:t>
-            </a:r>
-          </a:p>
-          <a:p>
-            <a:pPr>
-              <a:buNone/>
-            </a:pPr>
-            <a:r>
-              <a:rPr sz="1800">
-                <a:solidFill>
-                  <a:srgbClr val="222222"/>
-                </a:solidFill>
-              </a:rPr>
-              <a:t>Six workflow steps are Qwen-driven: recall extraction, inventory-match reasoning, risk classification, customer-notice drafting, shelf-photo interpretation, and the management briefing.</a:t>
-            </a:r>
-          </a:p>
-          <a:p>
-            <a:pPr>
-              <a:buNone/>
-            </a:pPr>
-            <a:r>
-              <a:rPr sz="1800">
-                <a:solidFill>
-                  <a:srgbClr val="222222"/>
-                </a:solidFill>
-              </a:rPr>
-              <a:t>Every Qwen response is validated against a Pydantic schema and repaired to a deterministic fallback on any failure, so the workflow never breaks.</a:t>
-            </a:r>
-          </a:p>
-          <a:p>
-            <a:pPr>
-              <a:buNone/>
-            </a:pPr>
-            <a:r>
-              <a:rPr sz="1800">
-                <a:solidFill>
-                  <a:srgbClr val="222222"/>
-                </a:solidFill>
-              </a:rPr>
-              <a:t>Two runtime modes: live (QWEN_API_KEY configured) and demo-fallback (deterministic outputs, used for reliable tests and demos without credentials).</a:t>
+        <p:spPr>
+          <a:xfrm>
+            <a:off x="685800" y="1504950"/>
+            <a:ext cx="4876800" cy="4762500"/>
+          </a:xfrm>
+        </p:spPr>
+        <p:txBody>
+          <a:bodyPr wrap="square" lIns="0" tIns="0" rIns="76200" bIns="0" anchor="t">
+            <a:normAutofit/>
+          </a:bodyPr>
+          <a:lstStyle/>
+          <a:p>
+            <a:pPr marL="0" indent="0" algn="l">
+              <a:spcAft>
+                <a:spcPts val="26"/>
+              </a:spcAft>
+              <a:buNone/>
+              <a:defRPr sz="1500" b="0">
+                <a:solidFill>
+                  <a:srgbClr val="132925"/>
+                </a:solidFill>
+                <a:latin typeface="Aptos"/>
+                <a:ea typeface="Aptos"/>
+                <a:cs typeface="Aptos"/>
+              </a:defRPr>
+            </a:pPr>
+            <a:r>
+              <a:rPr sz="1800" b="1" i="0">
+                <a:solidFill>
+                  <a:srgbClr val="132925"/>
+                </a:solidFill>
+                <a:latin typeface="Aptos"/>
+                <a:ea typeface="Aptos"/>
+                <a:cs typeface="Aptos"/>
+              </a:rPr>
+              <a:t>Qwen reasons where literal rules are not enough.</a:t>
+            </a:r>
+          </a:p>
+          <a:p>
+            <a:pPr marL="0" indent="0" algn="l">
+              <a:spcAft>
+                <a:spcPts val="14"/>
+              </a:spcAft>
+              <a:buNone/>
+              <a:defRPr sz="1500" b="0">
+                <a:solidFill>
+                  <a:srgbClr val="132925"/>
+                </a:solidFill>
+                <a:latin typeface="Aptos"/>
+                <a:ea typeface="Aptos"/>
+                <a:cs typeface="Aptos"/>
+              </a:defRPr>
+            </a:pPr>
+            <a:r>
+              <a:rPr sz="1125" b="1" i="0">
+                <a:solidFill>
+                  <a:srgbClr val="087C72"/>
+                </a:solidFill>
+                <a:latin typeface="Aptos"/>
+                <a:ea typeface="Aptos"/>
+                <a:cs typeface="Aptos"/>
+              </a:rPr>
+              <a:t>EXTRACT</a:t>
+            </a:r>
+            <a:r>
+              <a:rPr sz="1500" b="0" i="0">
+                <a:solidFill>
+                  <a:srgbClr val="132925"/>
+                </a:solidFill>
+                <a:latin typeface="Aptos"/>
+                <a:ea typeface="Aptos"/>
+                <a:cs typeface="Aptos"/>
+              </a:rPr>
+              <a:t>  Text and rendered-page recall evidence</a:t>
+            </a:r>
+          </a:p>
+          <a:p>
+            <a:pPr marL="0" indent="0" algn="l">
+              <a:spcAft>
+                <a:spcPts val="14"/>
+              </a:spcAft>
+              <a:buNone/>
+              <a:defRPr sz="1500" b="0">
+                <a:solidFill>
+                  <a:srgbClr val="132925"/>
+                </a:solidFill>
+                <a:latin typeface="Aptos"/>
+                <a:ea typeface="Aptos"/>
+                <a:cs typeface="Aptos"/>
+              </a:defRPr>
+            </a:pPr>
+            <a:r>
+              <a:rPr sz="1125" b="1" i="0">
+                <a:solidFill>
+                  <a:srgbClr val="087C72"/>
+                </a:solidFill>
+                <a:latin typeface="Aptos"/>
+                <a:ea typeface="Aptos"/>
+                <a:cs typeface="Aptos"/>
+              </a:rPr>
+              <a:t>SEE</a:t>
+            </a:r>
+            <a:r>
+              <a:rPr sz="1500" b="0" i="0">
+                <a:solidFill>
+                  <a:srgbClr val="132925"/>
+                </a:solidFill>
+                <a:latin typeface="Aptos"/>
+                <a:ea typeface="Aptos"/>
+                <a:cs typeface="Aptos"/>
+              </a:rPr>
+              <a:t>  Shelf-image interpretation</a:t>
+            </a:r>
+          </a:p>
+          <a:p>
+            <a:pPr marL="0" indent="0" algn="l">
+              <a:spcAft>
+                <a:spcPts val="14"/>
+              </a:spcAft>
+              <a:buNone/>
+              <a:defRPr sz="1500" b="0">
+                <a:solidFill>
+                  <a:srgbClr val="132925"/>
+                </a:solidFill>
+                <a:latin typeface="Aptos"/>
+                <a:ea typeface="Aptos"/>
+                <a:cs typeface="Aptos"/>
+              </a:defRPr>
+            </a:pPr>
+            <a:r>
+              <a:rPr sz="1125" b="1" i="0">
+                <a:solidFill>
+                  <a:srgbClr val="087C72"/>
+                </a:solidFill>
+                <a:latin typeface="Aptos"/>
+                <a:ea typeface="Aptos"/>
+                <a:cs typeface="Aptos"/>
+              </a:rPr>
+              <a:t>MATCH</a:t>
+            </a:r>
+            <a:r>
+              <a:rPr sz="1500" b="0" i="0">
+                <a:solidFill>
+                  <a:srgbClr val="132925"/>
+                </a:solidFill>
+                <a:latin typeface="Aptos"/>
+                <a:ea typeface="Aptos"/>
+                <a:cs typeface="Aptos"/>
+              </a:rPr>
+              <a:t>  Inventory reasoning across imperfect rows</a:t>
+            </a:r>
+          </a:p>
+          <a:p>
+            <a:pPr marL="0" indent="0" algn="l">
+              <a:spcAft>
+                <a:spcPts val="14"/>
+              </a:spcAft>
+              <a:buNone/>
+              <a:defRPr sz="1500" b="0">
+                <a:solidFill>
+                  <a:srgbClr val="132925"/>
+                </a:solidFill>
+                <a:latin typeface="Aptos"/>
+                <a:ea typeface="Aptos"/>
+                <a:cs typeface="Aptos"/>
+              </a:defRPr>
+            </a:pPr>
+            <a:r>
+              <a:rPr sz="1125" b="1" i="0">
+                <a:solidFill>
+                  <a:srgbClr val="087C72"/>
+                </a:solidFill>
+                <a:latin typeface="Aptos"/>
+                <a:ea typeface="Aptos"/>
+                <a:cs typeface="Aptos"/>
+              </a:rPr>
+              <a:t>CLASSIFY</a:t>
+            </a:r>
+            <a:r>
+              <a:rPr sz="1500" b="0" i="0">
+                <a:solidFill>
+                  <a:srgbClr val="132925"/>
+                </a:solidFill>
+                <a:latin typeface="Aptos"/>
+                <a:ea typeface="Aptos"/>
+                <a:cs typeface="Aptos"/>
+              </a:rPr>
+              <a:t>  Operational risk</a:t>
+            </a:r>
+          </a:p>
+          <a:p>
+            <a:pPr marL="0" indent="0" algn="l">
+              <a:spcAft>
+                <a:spcPts val="14"/>
+              </a:spcAft>
+              <a:buNone/>
+              <a:defRPr sz="1500" b="0">
+                <a:solidFill>
+                  <a:srgbClr val="132925"/>
+                </a:solidFill>
+                <a:latin typeface="Aptos"/>
+                <a:ea typeface="Aptos"/>
+                <a:cs typeface="Aptos"/>
+              </a:defRPr>
+            </a:pPr>
+            <a:r>
+              <a:rPr sz="1125" b="1" i="0">
+                <a:solidFill>
+                  <a:srgbClr val="087C72"/>
+                </a:solidFill>
+                <a:latin typeface="Aptos"/>
+                <a:ea typeface="Aptos"/>
+                <a:cs typeface="Aptos"/>
+              </a:rPr>
+              <a:t>WRITE</a:t>
+            </a:r>
+            <a:r>
+              <a:rPr sz="1500" b="0" i="0">
+                <a:solidFill>
+                  <a:srgbClr val="132925"/>
+                </a:solidFill>
+                <a:latin typeface="Aptos"/>
+                <a:ea typeface="Aptos"/>
+                <a:cs typeface="Aptos"/>
+              </a:rPr>
+              <a:t>  Customer communication</a:t>
+            </a:r>
+          </a:p>
+          <a:p>
+            <a:pPr marL="0" indent="0" algn="l">
+              <a:spcAft>
+                <a:spcPts val="14"/>
+              </a:spcAft>
+              <a:buNone/>
+              <a:defRPr sz="1500" b="0">
+                <a:solidFill>
+                  <a:srgbClr val="132925"/>
+                </a:solidFill>
+                <a:latin typeface="Aptos"/>
+                <a:ea typeface="Aptos"/>
+                <a:cs typeface="Aptos"/>
+              </a:defRPr>
+            </a:pPr>
+            <a:r>
+              <a:rPr sz="1125" b="1" i="0">
+                <a:solidFill>
+                  <a:srgbClr val="087C72"/>
+                </a:solidFill>
+                <a:latin typeface="Aptos"/>
+                <a:ea typeface="Aptos"/>
+                <a:cs typeface="Aptos"/>
+              </a:rPr>
+              <a:t>BRIEF</a:t>
+            </a:r>
+            <a:r>
+              <a:rPr sz="1500" b="0" i="0">
+                <a:solidFill>
+                  <a:srgbClr val="132925"/>
+                </a:solidFill>
+                <a:latin typeface="Aptos"/>
+                <a:ea typeface="Aptos"/>
+                <a:cs typeface="Aptos"/>
+              </a:rPr>
+              <a:t>  Management decision summary</a:t>
+            </a:r>
+          </a:p>
+        </p:txBody>
+      </p:sp>
+      <p:sp>
+        <p:nvSpPr>
+          <p:cNvPr id="4" name="Rectangle 3">
+            <a:extLst>
+              <a:ext uri="{FF2B5EF4-FFF2-40B4-BE49-F238E27FC236}">
+                <a16:creationId xmlns:a16="http://schemas.microsoft.com/office/drawing/2014/main" id="{C8584D73-AD4A-4E85-A0B5-E18B7830F84C}"/>
+              </a:ext>
+            </a:extLst>
+          </p:cNvPr>
+          <p:cNvSpPr>
+            <a:spLocks noGrp="1"/>
+          </p:cNvSpPr>
+          <p:nvPr/>
+        </p:nvSpPr>
+        <p:spPr>
+          <a:xfrm>
+            <a:off x="6400800" y="1581150"/>
+            <a:ext cx="4381500" cy="457200"/>
+          </a:xfrm>
+          <a:prstGeom prst="rect">
+            <a:avLst/>
+          </a:prstGeom>
+          <a:noFill/>
+          <a:ln w="0">
+            <a:noFill/>
+            <a:prstDash val="solid"/>
+          </a:ln>
+        </p:spPr>
+        <p:txBody>
+          <a:bodyPr wrap="square" lIns="0" tIns="0" rIns="0" bIns="0" anchor="t">
+            <a:normAutofit/>
+          </a:bodyPr>
+          <a:lstStyle/>
+          <a:p>
+            <a:pPr marL="0" indent="0" algn="l">
+              <a:spcAft>
+                <a:spcPts val="0"/>
+              </a:spcAft>
+              <a:buNone/>
+              <a:defRPr sz="2025" b="0">
+                <a:solidFill>
+                  <a:srgbClr val="132925"/>
+                </a:solidFill>
+                <a:latin typeface="Aptos"/>
+                <a:ea typeface="Aptos"/>
+                <a:cs typeface="Aptos"/>
+              </a:defRPr>
+            </a:pPr>
+            <a:r>
+              <a:rPr sz="2025" b="1" i="0">
+                <a:solidFill>
+                  <a:srgbClr val="0B3D38"/>
+                </a:solidFill>
+                <a:latin typeface="Aptos"/>
+                <a:ea typeface="Aptos"/>
+                <a:cs typeface="Aptos"/>
+              </a:rPr>
+              <a:t>Typed control</a:t>
+            </a:r>
+          </a:p>
+        </p:txBody>
+      </p:sp>
+      <p:sp>
+        <p:nvSpPr>
+          <p:cNvPr id="5" name="Rectangle 4">
+            <a:extLst>
+              <a:ext uri="{FF2B5EF4-FFF2-40B4-BE49-F238E27FC236}">
+                <a16:creationId xmlns:a16="http://schemas.microsoft.com/office/drawing/2014/main" id="{49DB38AB-AB7C-4A4F-A99D-4E2FEA9214AB}"/>
+              </a:ext>
+            </a:extLst>
+          </p:cNvPr>
+          <p:cNvSpPr>
+            <a:spLocks noGrp="1"/>
+          </p:cNvSpPr>
+          <p:nvPr/>
+        </p:nvSpPr>
+        <p:spPr>
+          <a:xfrm>
+            <a:off x="6400800" y="2314575"/>
+            <a:ext cx="304800" cy="19050"/>
+          </a:xfrm>
+          <a:prstGeom prst="rect">
+            <a:avLst/>
+          </a:prstGeom>
+          <a:solidFill>
+            <a:srgbClr val="087C72"/>
+          </a:solidFill>
+          <a:ln w="0">
+            <a:solidFill>
+              <a:srgbClr val="087C72"/>
+            </a:solidFill>
+            <a:prstDash val="solid"/>
+          </a:ln>
+        </p:spPr>
+        <p:txBody>
+          <a:bodyPr/>
+          <a:lstStyle/>
+          <a:p>
+            <a:endParaRPr lang="en-US"/>
+          </a:p>
+        </p:txBody>
+      </p:sp>
+      <p:sp>
+        <p:nvSpPr>
+          <p:cNvPr id="6" name="Rectangle 5">
+            <a:extLst>
+              <a:ext uri="{FF2B5EF4-FFF2-40B4-BE49-F238E27FC236}">
+                <a16:creationId xmlns:a16="http://schemas.microsoft.com/office/drawing/2014/main" id="{E3DA5237-1074-41E6-BEA6-93001745959B}"/>
+              </a:ext>
+            </a:extLst>
+          </p:cNvPr>
+          <p:cNvSpPr>
+            <a:spLocks noGrp="1"/>
+          </p:cNvSpPr>
+          <p:nvPr/>
+        </p:nvSpPr>
+        <p:spPr>
+          <a:xfrm>
+            <a:off x="6819900" y="2247900"/>
+            <a:ext cx="4095750" cy="323850"/>
+          </a:xfrm>
+          <a:prstGeom prst="rect">
+            <a:avLst/>
+          </a:prstGeom>
+          <a:noFill/>
+          <a:ln w="0">
+            <a:noFill/>
+            <a:prstDash val="solid"/>
+          </a:ln>
+        </p:spPr>
+        <p:txBody>
+          <a:bodyPr wrap="square" lIns="0" tIns="0" rIns="0" bIns="0" anchor="ctr">
+            <a:normAutofit/>
+          </a:bodyPr>
+          <a:lstStyle/>
+          <a:p>
+            <a:pPr marL="0" indent="0" algn="l">
+              <a:spcAft>
+                <a:spcPts val="0"/>
+              </a:spcAft>
+              <a:buNone/>
+              <a:defRPr sz="1500" b="0">
+                <a:solidFill>
+                  <a:srgbClr val="132925"/>
+                </a:solidFill>
+                <a:latin typeface="Aptos"/>
+                <a:ea typeface="Aptos"/>
+                <a:cs typeface="Aptos"/>
+              </a:defRPr>
+            </a:pPr>
+            <a:r>
+              <a:rPr sz="1125" b="1" i="0">
+                <a:solidFill>
+                  <a:srgbClr val="087C72"/>
+                </a:solidFill>
+                <a:latin typeface="Aptos"/>
+                <a:ea typeface="Aptos"/>
+                <a:cs typeface="Aptos"/>
+              </a:rPr>
+              <a:t>01</a:t>
+            </a:r>
+            <a:r>
+              <a:rPr sz="1500" b="0" i="0">
+                <a:solidFill>
+                  <a:srgbClr val="132925"/>
+                </a:solidFill>
+                <a:latin typeface="Aptos"/>
+                <a:ea typeface="Aptos"/>
+                <a:cs typeface="Aptos"/>
+              </a:rPr>
+              <a:t>   Structured JSON requests</a:t>
+            </a:r>
+          </a:p>
+        </p:txBody>
+      </p:sp>
+      <p:sp>
+        <p:nvSpPr>
+          <p:cNvPr id="7" name="Rectangle 6">
+            <a:extLst>
+              <a:ext uri="{FF2B5EF4-FFF2-40B4-BE49-F238E27FC236}">
+                <a16:creationId xmlns:a16="http://schemas.microsoft.com/office/drawing/2014/main" id="{EFC9E596-08BE-4DF3-85FA-17C060743901}"/>
+              </a:ext>
+            </a:extLst>
+          </p:cNvPr>
+          <p:cNvSpPr>
+            <a:spLocks noGrp="1"/>
+          </p:cNvSpPr>
+          <p:nvPr/>
+        </p:nvSpPr>
+        <p:spPr>
+          <a:xfrm>
+            <a:off x="6400800" y="2828925"/>
+            <a:ext cx="304800" cy="19050"/>
+          </a:xfrm>
+          <a:prstGeom prst="rect">
+            <a:avLst/>
+          </a:prstGeom>
+          <a:solidFill>
+            <a:srgbClr val="087C72"/>
+          </a:solidFill>
+          <a:ln w="0">
+            <a:solidFill>
+              <a:srgbClr val="087C72"/>
+            </a:solidFill>
+            <a:prstDash val="solid"/>
+          </a:ln>
+        </p:spPr>
+        <p:txBody>
+          <a:bodyPr/>
+          <a:lstStyle/>
+          <a:p>
+            <a:endParaRPr lang="en-US"/>
+          </a:p>
+        </p:txBody>
+      </p:sp>
+      <p:sp>
+        <p:nvSpPr>
+          <p:cNvPr id="8" name="Rectangle 7">
+            <a:extLst>
+              <a:ext uri="{FF2B5EF4-FFF2-40B4-BE49-F238E27FC236}">
+                <a16:creationId xmlns:a16="http://schemas.microsoft.com/office/drawing/2014/main" id="{9D79E248-48DE-4726-8F29-A7B904595117}"/>
+              </a:ext>
+            </a:extLst>
+          </p:cNvPr>
+          <p:cNvSpPr>
+            <a:spLocks noGrp="1"/>
+          </p:cNvSpPr>
+          <p:nvPr/>
+        </p:nvSpPr>
+        <p:spPr>
+          <a:xfrm>
+            <a:off x="6819900" y="2762250"/>
+            <a:ext cx="4095750" cy="323850"/>
+          </a:xfrm>
+          <a:prstGeom prst="rect">
+            <a:avLst/>
+          </a:prstGeom>
+          <a:noFill/>
+          <a:ln w="0">
+            <a:noFill/>
+            <a:prstDash val="solid"/>
+          </a:ln>
+        </p:spPr>
+        <p:txBody>
+          <a:bodyPr wrap="square" lIns="0" tIns="0" rIns="0" bIns="0" anchor="ctr">
+            <a:normAutofit/>
+          </a:bodyPr>
+          <a:lstStyle/>
+          <a:p>
+            <a:pPr marL="0" indent="0" algn="l">
+              <a:spcAft>
+                <a:spcPts val="0"/>
+              </a:spcAft>
+              <a:buNone/>
+              <a:defRPr sz="1500" b="0">
+                <a:solidFill>
+                  <a:srgbClr val="132925"/>
+                </a:solidFill>
+                <a:latin typeface="Aptos"/>
+                <a:ea typeface="Aptos"/>
+                <a:cs typeface="Aptos"/>
+              </a:defRPr>
+            </a:pPr>
+            <a:r>
+              <a:rPr sz="1125" b="1" i="0">
+                <a:solidFill>
+                  <a:srgbClr val="087C72"/>
+                </a:solidFill>
+                <a:latin typeface="Aptos"/>
+                <a:ea typeface="Aptos"/>
+                <a:cs typeface="Aptos"/>
+              </a:rPr>
+              <a:t>02</a:t>
+            </a:r>
+            <a:r>
+              <a:rPr sz="1500" b="0" i="0">
+                <a:solidFill>
+                  <a:srgbClr val="132925"/>
+                </a:solidFill>
+                <a:latin typeface="Aptos"/>
+                <a:ea typeface="Aptos"/>
+                <a:cs typeface="Aptos"/>
+              </a:rPr>
+              <a:t>   Pydantic validation</a:t>
+            </a:r>
+          </a:p>
+        </p:txBody>
+      </p:sp>
+      <p:sp>
+        <p:nvSpPr>
+          <p:cNvPr id="9" name="Rectangle 8">
+            <a:extLst>
+              <a:ext uri="{FF2B5EF4-FFF2-40B4-BE49-F238E27FC236}">
+                <a16:creationId xmlns:a16="http://schemas.microsoft.com/office/drawing/2014/main" id="{6D5F2987-D25E-4119-AAC8-8264DACC307B}"/>
+              </a:ext>
+            </a:extLst>
+          </p:cNvPr>
+          <p:cNvSpPr>
+            <a:spLocks noGrp="1"/>
+          </p:cNvSpPr>
+          <p:nvPr/>
+        </p:nvSpPr>
+        <p:spPr>
+          <a:xfrm>
+            <a:off x="6400800" y="3343275"/>
+            <a:ext cx="304800" cy="19050"/>
+          </a:xfrm>
+          <a:prstGeom prst="rect">
+            <a:avLst/>
+          </a:prstGeom>
+          <a:solidFill>
+            <a:srgbClr val="087C72"/>
+          </a:solidFill>
+          <a:ln w="0">
+            <a:solidFill>
+              <a:srgbClr val="087C72"/>
+            </a:solidFill>
+            <a:prstDash val="solid"/>
+          </a:ln>
+        </p:spPr>
+        <p:txBody>
+          <a:bodyPr/>
+          <a:lstStyle/>
+          <a:p>
+            <a:endParaRPr lang="en-US"/>
+          </a:p>
+        </p:txBody>
+      </p:sp>
+      <p:sp>
+        <p:nvSpPr>
+          <p:cNvPr id="10" name="Rectangle 9">
+            <a:extLst>
+              <a:ext uri="{FF2B5EF4-FFF2-40B4-BE49-F238E27FC236}">
+                <a16:creationId xmlns:a16="http://schemas.microsoft.com/office/drawing/2014/main" id="{C0B5066D-2CA3-4354-88FF-0FAA5F182691}"/>
+              </a:ext>
+            </a:extLst>
+          </p:cNvPr>
+          <p:cNvSpPr>
+            <a:spLocks noGrp="1"/>
+          </p:cNvSpPr>
+          <p:nvPr/>
+        </p:nvSpPr>
+        <p:spPr>
+          <a:xfrm>
+            <a:off x="6819900" y="3276600"/>
+            <a:ext cx="4095750" cy="323850"/>
+          </a:xfrm>
+          <a:prstGeom prst="rect">
+            <a:avLst/>
+          </a:prstGeom>
+          <a:noFill/>
+          <a:ln w="0">
+            <a:noFill/>
+            <a:prstDash val="solid"/>
+          </a:ln>
+        </p:spPr>
+        <p:txBody>
+          <a:bodyPr wrap="square" lIns="0" tIns="0" rIns="0" bIns="0" anchor="ctr">
+            <a:normAutofit/>
+          </a:bodyPr>
+          <a:lstStyle/>
+          <a:p>
+            <a:pPr marL="0" indent="0" algn="l">
+              <a:spcAft>
+                <a:spcPts val="0"/>
+              </a:spcAft>
+              <a:buNone/>
+              <a:defRPr sz="1500" b="0">
+                <a:solidFill>
+                  <a:srgbClr val="132925"/>
+                </a:solidFill>
+                <a:latin typeface="Aptos"/>
+                <a:ea typeface="Aptos"/>
+                <a:cs typeface="Aptos"/>
+              </a:defRPr>
+            </a:pPr>
+            <a:r>
+              <a:rPr sz="1125" b="1" i="0">
+                <a:solidFill>
+                  <a:srgbClr val="087C72"/>
+                </a:solidFill>
+                <a:latin typeface="Aptos"/>
+                <a:ea typeface="Aptos"/>
+                <a:cs typeface="Aptos"/>
+              </a:rPr>
+              <a:t>03</a:t>
+            </a:r>
+            <a:r>
+              <a:rPr sz="1500" b="0" i="0">
+                <a:solidFill>
+                  <a:srgbClr val="132925"/>
+                </a:solidFill>
+                <a:latin typeface="Aptos"/>
+                <a:ea typeface="Aptos"/>
+                <a:cs typeface="Aptos"/>
+              </a:rPr>
+              <a:t>   Explicit provider source</a:t>
+            </a:r>
+          </a:p>
+        </p:txBody>
+      </p:sp>
+      <p:sp>
+        <p:nvSpPr>
+          <p:cNvPr id="11" name="Rectangle 10">
+            <a:extLst>
+              <a:ext uri="{FF2B5EF4-FFF2-40B4-BE49-F238E27FC236}">
+                <a16:creationId xmlns:a16="http://schemas.microsoft.com/office/drawing/2014/main" id="{57DFB12F-8FDB-4B31-A927-13C6316248D5}"/>
+              </a:ext>
+            </a:extLst>
+          </p:cNvPr>
+          <p:cNvSpPr>
+            <a:spLocks noGrp="1"/>
+          </p:cNvSpPr>
+          <p:nvPr/>
+        </p:nvSpPr>
+        <p:spPr>
+          <a:xfrm>
+            <a:off x="6400800" y="3857625"/>
+            <a:ext cx="304800" cy="19050"/>
+          </a:xfrm>
+          <a:prstGeom prst="rect">
+            <a:avLst/>
+          </a:prstGeom>
+          <a:solidFill>
+            <a:srgbClr val="087C72"/>
+          </a:solidFill>
+          <a:ln w="0">
+            <a:solidFill>
+              <a:srgbClr val="087C72"/>
+            </a:solidFill>
+            <a:prstDash val="solid"/>
+          </a:ln>
+        </p:spPr>
+        <p:txBody>
+          <a:bodyPr/>
+          <a:lstStyle/>
+          <a:p>
+            <a:endParaRPr lang="en-US"/>
+          </a:p>
+        </p:txBody>
+      </p:sp>
+      <p:sp>
+        <p:nvSpPr>
+          <p:cNvPr id="12" name="Rectangle 11">
+            <a:extLst>
+              <a:ext uri="{FF2B5EF4-FFF2-40B4-BE49-F238E27FC236}">
+                <a16:creationId xmlns:a16="http://schemas.microsoft.com/office/drawing/2014/main" id="{5B0460DF-E78A-4095-BBE2-0CD3F0C79C0C}"/>
+              </a:ext>
+            </a:extLst>
+          </p:cNvPr>
+          <p:cNvSpPr>
+            <a:spLocks noGrp="1"/>
+          </p:cNvSpPr>
+          <p:nvPr/>
+        </p:nvSpPr>
+        <p:spPr>
+          <a:xfrm>
+            <a:off x="6819900" y="3790950"/>
+            <a:ext cx="4095750" cy="323850"/>
+          </a:xfrm>
+          <a:prstGeom prst="rect">
+            <a:avLst/>
+          </a:prstGeom>
+          <a:noFill/>
+          <a:ln w="0">
+            <a:noFill/>
+            <a:prstDash val="solid"/>
+          </a:ln>
+        </p:spPr>
+        <p:txBody>
+          <a:bodyPr wrap="square" lIns="0" tIns="0" rIns="0" bIns="0" anchor="ctr">
+            <a:normAutofit/>
+          </a:bodyPr>
+          <a:lstStyle/>
+          <a:p>
+            <a:pPr marL="0" indent="0" algn="l">
+              <a:spcAft>
+                <a:spcPts val="0"/>
+              </a:spcAft>
+              <a:buNone/>
+              <a:defRPr sz="1500" b="0">
+                <a:solidFill>
+                  <a:srgbClr val="132925"/>
+                </a:solidFill>
+                <a:latin typeface="Aptos"/>
+                <a:ea typeface="Aptos"/>
+                <a:cs typeface="Aptos"/>
+              </a:defRPr>
+            </a:pPr>
+            <a:r>
+              <a:rPr sz="1125" b="1" i="0">
+                <a:solidFill>
+                  <a:srgbClr val="087C72"/>
+                </a:solidFill>
+                <a:latin typeface="Aptos"/>
+                <a:ea typeface="Aptos"/>
+                <a:cs typeface="Aptos"/>
+              </a:rPr>
+              <a:t>04</a:t>
+            </a:r>
+            <a:r>
+              <a:rPr sz="1500" b="0" i="0">
+                <a:solidFill>
+                  <a:srgbClr val="132925"/>
+                </a:solidFill>
+                <a:latin typeface="Aptos"/>
+                <a:ea typeface="Aptos"/>
+                <a:cs typeface="Aptos"/>
+              </a:rPr>
+              <a:t>   Bounded retries</a:t>
+            </a:r>
+          </a:p>
+        </p:txBody>
+      </p:sp>
+      <p:sp>
+        <p:nvSpPr>
+          <p:cNvPr id="13" name="Rectangle 12">
+            <a:extLst>
+              <a:ext uri="{FF2B5EF4-FFF2-40B4-BE49-F238E27FC236}">
+                <a16:creationId xmlns:a16="http://schemas.microsoft.com/office/drawing/2014/main" id="{A39D5B80-1B5B-4286-9620-92C429A8B330}"/>
+              </a:ext>
+            </a:extLst>
+          </p:cNvPr>
+          <p:cNvSpPr>
+            <a:spLocks noGrp="1"/>
+          </p:cNvSpPr>
+          <p:nvPr/>
+        </p:nvSpPr>
+        <p:spPr>
+          <a:xfrm>
+            <a:off x="6400800" y="4371975"/>
+            <a:ext cx="304800" cy="19050"/>
+          </a:xfrm>
+          <a:prstGeom prst="rect">
+            <a:avLst/>
+          </a:prstGeom>
+          <a:solidFill>
+            <a:srgbClr val="087C72"/>
+          </a:solidFill>
+          <a:ln w="0">
+            <a:solidFill>
+              <a:srgbClr val="087C72"/>
+            </a:solidFill>
+            <a:prstDash val="solid"/>
+          </a:ln>
+        </p:spPr>
+        <p:txBody>
+          <a:bodyPr/>
+          <a:lstStyle/>
+          <a:p>
+            <a:endParaRPr lang="en-US"/>
+          </a:p>
+        </p:txBody>
+      </p:sp>
+      <p:sp>
+        <p:nvSpPr>
+          <p:cNvPr id="14" name="Rectangle 13">
+            <a:extLst>
+              <a:ext uri="{FF2B5EF4-FFF2-40B4-BE49-F238E27FC236}">
+                <a16:creationId xmlns:a16="http://schemas.microsoft.com/office/drawing/2014/main" id="{041887C9-0313-4101-90F4-BA7FF15B84C4}"/>
+              </a:ext>
+            </a:extLst>
+          </p:cNvPr>
+          <p:cNvSpPr>
+            <a:spLocks noGrp="1"/>
+          </p:cNvSpPr>
+          <p:nvPr/>
+        </p:nvSpPr>
+        <p:spPr>
+          <a:xfrm>
+            <a:off x="6819900" y="4305300"/>
+            <a:ext cx="4095750" cy="323850"/>
+          </a:xfrm>
+          <a:prstGeom prst="rect">
+            <a:avLst/>
+          </a:prstGeom>
+          <a:noFill/>
+          <a:ln w="0">
+            <a:noFill/>
+            <a:prstDash val="solid"/>
+          </a:ln>
+        </p:spPr>
+        <p:txBody>
+          <a:bodyPr wrap="square" lIns="0" tIns="0" rIns="0" bIns="0" anchor="ctr">
+            <a:normAutofit/>
+          </a:bodyPr>
+          <a:lstStyle/>
+          <a:p>
+            <a:pPr marL="0" indent="0" algn="l">
+              <a:spcAft>
+                <a:spcPts val="0"/>
+              </a:spcAft>
+              <a:buNone/>
+              <a:defRPr sz="1500" b="0">
+                <a:solidFill>
+                  <a:srgbClr val="132925"/>
+                </a:solidFill>
+                <a:latin typeface="Aptos"/>
+                <a:ea typeface="Aptos"/>
+                <a:cs typeface="Aptos"/>
+              </a:defRPr>
+            </a:pPr>
+            <a:r>
+              <a:rPr sz="1125" b="1" i="0">
+                <a:solidFill>
+                  <a:srgbClr val="087C72"/>
+                </a:solidFill>
+                <a:latin typeface="Aptos"/>
+                <a:ea typeface="Aptos"/>
+                <a:cs typeface="Aptos"/>
+              </a:rPr>
+              <a:t>05</a:t>
+            </a:r>
+            <a:r>
+              <a:rPr sz="1500" b="0" i="0">
+                <a:solidFill>
+                  <a:srgbClr val="132925"/>
+                </a:solidFill>
+                <a:latin typeface="Aptos"/>
+                <a:ea typeface="Aptos"/>
+                <a:cs typeface="Aptos"/>
+              </a:rPr>
+              <a:t>   Neutral or literal fallback</a:t>
+            </a:r>
+          </a:p>
+        </p:txBody>
+      </p:sp>
+      <p:sp>
+        <p:nvSpPr>
+          <p:cNvPr id="15" name="Rectangle 14">
+            <a:extLst>
+              <a:ext uri="{FF2B5EF4-FFF2-40B4-BE49-F238E27FC236}">
+                <a16:creationId xmlns:a16="http://schemas.microsoft.com/office/drawing/2014/main" id="{134E4B33-BAAC-4BC3-A75A-AC4EC8CE840B}"/>
+              </a:ext>
+            </a:extLst>
+          </p:cNvPr>
+          <p:cNvSpPr>
+            <a:spLocks noGrp="1"/>
+          </p:cNvSpPr>
+          <p:nvPr/>
+        </p:nvSpPr>
+        <p:spPr>
+          <a:xfrm>
+            <a:off x="6400800" y="4886325"/>
+            <a:ext cx="304800" cy="19050"/>
+          </a:xfrm>
+          <a:prstGeom prst="rect">
+            <a:avLst/>
+          </a:prstGeom>
+          <a:solidFill>
+            <a:srgbClr val="087C72"/>
+          </a:solidFill>
+          <a:ln w="0">
+            <a:solidFill>
+              <a:srgbClr val="087C72"/>
+            </a:solidFill>
+            <a:prstDash val="solid"/>
+          </a:ln>
+        </p:spPr>
+        <p:txBody>
+          <a:bodyPr/>
+          <a:lstStyle/>
+          <a:p>
+            <a:endParaRPr lang="en-US"/>
+          </a:p>
+        </p:txBody>
+      </p:sp>
+      <p:sp>
+        <p:nvSpPr>
+          <p:cNvPr id="16" name="Rectangle 15">
+            <a:extLst>
+              <a:ext uri="{FF2B5EF4-FFF2-40B4-BE49-F238E27FC236}">
+                <a16:creationId xmlns:a16="http://schemas.microsoft.com/office/drawing/2014/main" id="{BC703536-F208-4981-B203-65FEF62FB97A}"/>
+              </a:ext>
+            </a:extLst>
+          </p:cNvPr>
+          <p:cNvSpPr>
+            <a:spLocks noGrp="1"/>
+          </p:cNvSpPr>
+          <p:nvPr/>
+        </p:nvSpPr>
+        <p:spPr>
+          <a:xfrm>
+            <a:off x="6819900" y="4819650"/>
+            <a:ext cx="4095750" cy="323850"/>
+          </a:xfrm>
+          <a:prstGeom prst="rect">
+            <a:avLst/>
+          </a:prstGeom>
+          <a:noFill/>
+          <a:ln w="0">
+            <a:noFill/>
+            <a:prstDash val="solid"/>
+          </a:ln>
+        </p:spPr>
+        <p:txBody>
+          <a:bodyPr wrap="square" lIns="0" tIns="0" rIns="0" bIns="0" anchor="ctr">
+            <a:normAutofit/>
+          </a:bodyPr>
+          <a:lstStyle/>
+          <a:p>
+            <a:pPr marL="0" indent="0" algn="l">
+              <a:spcAft>
+                <a:spcPts val="0"/>
+              </a:spcAft>
+              <a:buNone/>
+              <a:defRPr sz="1500" b="0">
+                <a:solidFill>
+                  <a:srgbClr val="132925"/>
+                </a:solidFill>
+                <a:latin typeface="Aptos"/>
+                <a:ea typeface="Aptos"/>
+                <a:cs typeface="Aptos"/>
+              </a:defRPr>
+            </a:pPr>
+            <a:r>
+              <a:rPr sz="1125" b="1" i="0">
+                <a:solidFill>
+                  <a:srgbClr val="087C72"/>
+                </a:solidFill>
+                <a:latin typeface="Aptos"/>
+                <a:ea typeface="Aptos"/>
+                <a:cs typeface="Aptos"/>
+              </a:rPr>
+              <a:t>06</a:t>
+            </a:r>
+            <a:r>
+              <a:rPr sz="1500" b="0" i="0">
+                <a:solidFill>
+                  <a:srgbClr val="132925"/>
+                </a:solidFill>
+                <a:latin typeface="Aptos"/>
+                <a:ea typeface="Aptos"/>
+                <a:cs typeface="Aptos"/>
+              </a:rPr>
+              <a:t>   Reviewer escalation</a:t>
+            </a:r>
+          </a:p>
+        </p:txBody>
+      </p:sp>
+      <p:sp>
+        <p:nvSpPr>
+          <p:cNvPr id="17" name="Rounded Rectangle 16">
+            <a:extLst>
+              <a:ext uri="{FF2B5EF4-FFF2-40B4-BE49-F238E27FC236}">
+                <a16:creationId xmlns:a16="http://schemas.microsoft.com/office/drawing/2014/main" id="{C70B5286-C410-45B7-8366-7B2BDAF15EF1}"/>
+              </a:ext>
+            </a:extLst>
+          </p:cNvPr>
+          <p:cNvSpPr>
+            <a:spLocks noGrp="1"/>
+          </p:cNvSpPr>
+          <p:nvPr/>
+        </p:nvSpPr>
+        <p:spPr>
+          <a:xfrm>
+            <a:off x="6400800" y="5486400"/>
+            <a:ext cx="4762500" cy="647700"/>
+          </a:xfrm>
+          <a:prstGeom prst="roundRect">
+            <a:avLst>
+              <a:gd name="adj" fmla="val 8824"/>
+            </a:avLst>
+          </a:prstGeom>
+          <a:solidFill>
+            <a:srgbClr val="E6F3F1"/>
+          </a:solidFill>
+          <a:ln w="9525">
+            <a:solidFill>
+              <a:srgbClr val="B8DAD6"/>
+            </a:solidFill>
+            <a:prstDash val="solid"/>
+          </a:ln>
+        </p:spPr>
+        <p:txBody>
+          <a:bodyPr/>
+          <a:lstStyle/>
+          <a:p>
+            <a:endParaRPr lang="en-US"/>
+          </a:p>
+        </p:txBody>
+      </p:sp>
+      <p:sp>
+        <p:nvSpPr>
+          <p:cNvPr id="18" name="Rectangle 17">
+            <a:extLst>
+              <a:ext uri="{FF2B5EF4-FFF2-40B4-BE49-F238E27FC236}">
+                <a16:creationId xmlns:a16="http://schemas.microsoft.com/office/drawing/2014/main" id="{42095DF7-0447-4EA6-912C-3ECB67796EBD}"/>
+              </a:ext>
+            </a:extLst>
+          </p:cNvPr>
+          <p:cNvSpPr>
+            <a:spLocks noGrp="1"/>
+          </p:cNvSpPr>
+          <p:nvPr/>
+        </p:nvSpPr>
+        <p:spPr>
+          <a:xfrm>
+            <a:off x="6610350" y="5619750"/>
+            <a:ext cx="4343400" cy="381000"/>
+          </a:xfrm>
+          <a:prstGeom prst="rect">
+            <a:avLst/>
+          </a:prstGeom>
+          <a:noFill/>
+          <a:ln w="0">
+            <a:noFill/>
+            <a:prstDash val="solid"/>
+          </a:ln>
+        </p:spPr>
+        <p:txBody>
+          <a:bodyPr wrap="square" lIns="0" tIns="0" rIns="0" bIns="0" anchor="ctr">
+            <a:normAutofit fontScale="92593"/>
+          </a:bodyPr>
+          <a:lstStyle/>
+          <a:p>
+            <a:pPr marL="0" indent="0" algn="l">
+              <a:spcAft>
+                <a:spcPts val="0"/>
+              </a:spcAft>
+              <a:buNone/>
+              <a:defRPr sz="1350" b="0">
+                <a:solidFill>
+                  <a:srgbClr val="132925"/>
+                </a:solidFill>
+                <a:latin typeface="Aptos"/>
+                <a:ea typeface="Aptos"/>
+                <a:cs typeface="Aptos"/>
+              </a:defRPr>
+            </a:pPr>
+            <a:r>
+              <a:rPr sz="1350" b="1" i="0">
+                <a:solidFill>
+                  <a:srgbClr val="0B3D38"/>
+                </a:solidFill>
+                <a:latin typeface="Aptos"/>
+                <a:ea typeface="Aptos"/>
+                <a:cs typeface="Aptos"/>
+              </a:rPr>
+              <a:t>Qwen handles uncertainty. Typed systems decide what may enter the workflow.</a:t>
             </a:r>
           </a:p>
         </p:txBody>
@@ -7440,6 +8523,14 @@
 <file path=ppt/slides/slide6.xml><?xml version="1.0" encoding="utf-8"?>
 <p:sld xmlns:a="http://schemas.openxmlformats.org/drawingml/2006/main" xmlns:r="http://schemas.openxmlformats.org/officeDocument/2006/relationships" xmlns:p="http://schemas.openxmlformats.org/presentationml/2006/main">
   <p:cSld>
+    <p:bg>
+      <p:bgPr>
+        <a:solidFill>
+          <a:srgbClr val="F8FBFA"/>
+        </a:solidFill>
+        <a:effectLst/>
+      </p:bgPr>
+    </p:bg>
     <p:spTree>
       <p:nvGrpSpPr>
         <p:cNvPr id="1" name=""/>
@@ -7470,21 +8561,42 @@
             <p:ph type="title"/>
           </p:nvPr>
         </p:nvSpPr>
-        <p:spPr/>
-        <p:txBody>
-          <a:bodyPr/>
-          <a:lstStyle/>
-          <a:p>
-            <a:pPr>
-              <a:buNone/>
-              <a:defRPr sz="3200">
-                <a:solidFill>
-                  <a:srgbClr val="1F6FEB"/>
-                </a:solidFill>
+        <p:spPr>
+          <a:xfrm>
+            <a:off x="609600" y="419100"/>
+            <a:ext cx="10934700" cy="781050"/>
+          </a:xfrm>
+        </p:spPr>
+        <p:txBody>
+          <a:bodyPr wrap="square" lIns="0" tIns="0" rIns="0" bIns="0" anchor="ctr">
+            <a:normAutofit/>
+          </a:bodyPr>
+          <a:lstStyle/>
+          <a:p>
+            <a:pPr marL="0" indent="0" algn="l">
+              <a:spcAft>
+                <a:spcPts val="0"/>
+              </a:spcAft>
+              <a:buNone/>
+              <a:defRPr sz="3600" b="1">
+                <a:solidFill>
+                  <a:srgbClr val="132925"/>
+                </a:solidFill>
+                <a:latin typeface="Aptos Display"/>
+                <a:ea typeface="Aptos Display"/>
+                <a:cs typeface="Aptos Display"/>
               </a:defRPr>
             </a:pPr>
             <a:r>
-              <a:t>Agent Society — Nine Specialists, One DAG</a:t>
+              <a:rPr sz="3600" b="1" i="0">
+                <a:solidFill>
+                  <a:srgbClr val="132925"/>
+                </a:solidFill>
+                <a:latin typeface="Aptos Display"/>
+                <a:ea typeface="Aptos Display"/>
+                <a:cs typeface="Aptos Display"/>
+              </a:rPr>
+              <a:t>Nine specialists share one typed blackboard</a:t>
             </a:r>
           </a:p>
         </p:txBody>
@@ -7505,64 +8617,1707 @@
             <p:ph idx="1"/>
           </p:nvPr>
         </p:nvSpPr>
-        <p:spPr/>
-        <p:txBody>
-          <a:bodyPr wrap="square"/>
-          <a:lstStyle/>
-          <a:p>
-            <a:pPr>
-              <a:buNone/>
-            </a:pPr>
-            <a:r>
-              <a:rPr sz="1800">
-                <a:solidFill>
-                  <a:srgbClr val="222222"/>
-                </a:solidFill>
-              </a:rPr>
-              <a:t>Recall Intake -&gt; Document Extraction -&gt; Inventory Matching / Shelf Vision -&gt; Risk Scoring / Memory -&gt; Operations Task / Communications -&gt; Compliance Evidence.</a:t>
-            </a:r>
-          </a:p>
-          <a:p>
-            <a:pPr>
-              <a:buNone/>
-            </a:pPr>
-            <a:r>
-              <a:rPr sz="1800">
-                <a:solidFill>
-                  <a:srgbClr val="222222"/>
-                </a:solidFill>
-              </a:rPr>
-              <a:t>Independent specialists run inside the same wave instead of one after another — six parallel waves in total for nine agents.</a:t>
-            </a:r>
-          </a:p>
-          <a:p>
-            <a:pPr>
-              <a:buNone/>
-            </a:pPr>
-            <a:r>
-              <a:rPr sz="1800">
-                <a:solidFill>
-                  <a:srgbClr val="222222"/>
-                </a:solidFill>
-              </a:rPr>
-              <a:t>Each agent gets per-attempt retries, and a failing agent's downstream dependents are skipped cleanly rather than aborting the whole run.</a:t>
-            </a:r>
-          </a:p>
-          <a:p>
-            <a:pPr>
-              <a:buNone/>
-            </a:pPr>
-            <a:r>
-              <a:rPr sz="1800">
-                <a:solidFill>
-                  <a:srgbClr val="222222"/>
-                </a:solidFill>
-              </a:rPr>
-              <a:t>The orchestrator reconciles disagreement between Qwen's reasoning and the authoritative inventory ground truth before assembling the final analysis.</a:t>
-            </a:r>
-          </a:p>
-        </p:txBody>
-      </p:sp>
+        <p:spPr>
+          <a:xfrm>
+            <a:off x="685800" y="1504950"/>
+            <a:ext cx="3048000" cy="4724400"/>
+          </a:xfrm>
+        </p:spPr>
+        <p:txBody>
+          <a:bodyPr wrap="square" lIns="0" tIns="0" rIns="76200" bIns="0" anchor="t">
+            <a:normAutofit/>
+          </a:bodyPr>
+          <a:lstStyle/>
+          <a:p>
+            <a:pPr marL="0" indent="0" algn="l">
+              <a:spcAft>
+                <a:spcPts val="28"/>
+              </a:spcAft>
+              <a:buNone/>
+              <a:defRPr sz="1425" b="0">
+                <a:solidFill>
+                  <a:srgbClr val="132925"/>
+                </a:solidFill>
+                <a:latin typeface="Aptos"/>
+                <a:ea typeface="Aptos"/>
+                <a:cs typeface="Aptos"/>
+              </a:defRPr>
+            </a:pPr>
+            <a:r>
+              <a:rPr sz="1800" b="1" i="0">
+                <a:solidFill>
+                  <a:srgbClr val="132925"/>
+                </a:solidFill>
+                <a:latin typeface="Aptos"/>
+                <a:ea typeface="Aptos"/>
+                <a:cs typeface="Aptos"/>
+              </a:rPr>
+              <a:t>The Agent Society advances in six durable waves.</a:t>
+            </a:r>
+          </a:p>
+          <a:p>
+            <a:pPr marL="0" indent="0" algn="l">
+              <a:spcAft>
+                <a:spcPts val="16"/>
+              </a:spcAft>
+              <a:buNone/>
+              <a:defRPr sz="1425" b="0">
+                <a:solidFill>
+                  <a:srgbClr val="132925"/>
+                </a:solidFill>
+                <a:latin typeface="Aptos"/>
+                <a:ea typeface="Aptos"/>
+                <a:cs typeface="Aptos"/>
+              </a:defRPr>
+            </a:pPr>
+            <a:r>
+              <a:rPr sz="2850" b="1" i="0">
+                <a:solidFill>
+                  <a:srgbClr val="087C72"/>
+                </a:solidFill>
+                <a:latin typeface="Aptos"/>
+                <a:ea typeface="Aptos"/>
+                <a:cs typeface="Aptos"/>
+              </a:rPr>
+              <a:t>9</a:t>
+            </a:r>
+            <a:r>
+              <a:rPr sz="1425" b="0" i="0">
+                <a:solidFill>
+                  <a:srgbClr val="5B6F6A"/>
+                </a:solidFill>
+                <a:latin typeface="Aptos"/>
+                <a:ea typeface="Aptos"/>
+                <a:cs typeface="Aptos"/>
+              </a:rPr>
+              <a:t> specialist agents</a:t>
+            </a:r>
+          </a:p>
+          <a:p>
+            <a:pPr marL="0" indent="0" algn="l">
+              <a:spcAft>
+                <a:spcPts val="26"/>
+              </a:spcAft>
+              <a:buNone/>
+              <a:defRPr sz="1425" b="0">
+                <a:solidFill>
+                  <a:srgbClr val="132925"/>
+                </a:solidFill>
+                <a:latin typeface="Aptos"/>
+                <a:ea typeface="Aptos"/>
+                <a:cs typeface="Aptos"/>
+              </a:defRPr>
+            </a:pPr>
+            <a:r>
+              <a:rPr sz="2850" b="1" i="0">
+                <a:solidFill>
+                  <a:srgbClr val="0B3D38"/>
+                </a:solidFill>
+                <a:latin typeface="Aptos"/>
+                <a:ea typeface="Aptos"/>
+                <a:cs typeface="Aptos"/>
+              </a:rPr>
+              <a:t>6</a:t>
+            </a:r>
+            <a:r>
+              <a:rPr sz="1425" b="0" i="0">
+                <a:solidFill>
+                  <a:srgbClr val="5B6F6A"/>
+                </a:solidFill>
+                <a:latin typeface="Aptos"/>
+                <a:ea typeface="Aptos"/>
+                <a:cs typeface="Aptos"/>
+              </a:rPr>
+              <a:t> typed waves</a:t>
+            </a:r>
+          </a:p>
+          <a:p>
+            <a:pPr marL="0" indent="0" algn="l">
+              <a:spcAft>
+                <a:spcPts val="16"/>
+              </a:spcAft>
+              <a:buNone/>
+              <a:defRPr sz="1425" b="0">
+                <a:solidFill>
+                  <a:srgbClr val="132925"/>
+                </a:solidFill>
+                <a:latin typeface="Aptos"/>
+                <a:ea typeface="Aptos"/>
+                <a:cs typeface="Aptos"/>
+              </a:defRPr>
+            </a:pPr>
+            <a:r>
+              <a:rPr sz="1425" b="0" i="0">
+                <a:solidFill>
+                  <a:srgbClr val="132925"/>
+                </a:solidFill>
+                <a:latin typeface="Aptos"/>
+                <a:ea typeface="Aptos"/>
+                <a:cs typeface="Aptos"/>
+              </a:rPr>
+              <a:t>Independent specialists run in parallel inside a wave.</a:t>
+            </a:r>
+          </a:p>
+          <a:p>
+            <a:pPr marL="0" indent="0" algn="l">
+              <a:spcAft>
+                <a:spcPts val="16"/>
+              </a:spcAft>
+              <a:buNone/>
+              <a:defRPr sz="1425" b="0">
+                <a:solidFill>
+                  <a:srgbClr val="132925"/>
+                </a:solidFill>
+                <a:latin typeface="Aptos"/>
+                <a:ea typeface="Aptos"/>
+                <a:cs typeface="Aptos"/>
+              </a:defRPr>
+            </a:pPr>
+            <a:r>
+              <a:rPr sz="1425" b="0" i="0">
+                <a:solidFill>
+                  <a:srgbClr val="132925"/>
+                </a:solidFill>
+                <a:latin typeface="Aptos"/>
+                <a:ea typeface="Aptos"/>
+                <a:cs typeface="Aptos"/>
+              </a:rPr>
+              <a:t>Each wave writes a checkpoint before the next one begins.</a:t>
+            </a:r>
+          </a:p>
+          <a:p>
+            <a:pPr marL="0" indent="0" algn="l">
+              <a:spcAft>
+                <a:spcPts val="16"/>
+              </a:spcAft>
+              <a:buNone/>
+              <a:defRPr sz="1425" b="0">
+                <a:solidFill>
+                  <a:srgbClr val="132925"/>
+                </a:solidFill>
+                <a:latin typeface="Aptos"/>
+                <a:ea typeface="Aptos"/>
+                <a:cs typeface="Aptos"/>
+              </a:defRPr>
+            </a:pPr>
+            <a:r>
+              <a:rPr sz="1425" b="0" i="0">
+                <a:solidFill>
+                  <a:srgbClr val="132925"/>
+                </a:solidFill>
+                <a:latin typeface="Aptos"/>
+                <a:ea typeface="Aptos"/>
+                <a:cs typeface="Aptos"/>
+              </a:rPr>
+              <a:t>Failure skips only dependent work, preserving useful results.</a:t>
+            </a:r>
+          </a:p>
+        </p:txBody>
+      </p:sp>
+      <p:sp>
+        <p:nvSpPr>
+          <p:cNvPr id="4" name="Rectangle 3">
+            <a:extLst>
+              <a:ext uri="{FF2B5EF4-FFF2-40B4-BE49-F238E27FC236}">
+                <a16:creationId xmlns:a16="http://schemas.microsoft.com/office/drawing/2014/main" id="{29EEA03C-86AC-4A5B-B91F-F6A4015AA49C}"/>
+              </a:ext>
+            </a:extLst>
+          </p:cNvPr>
+          <p:cNvSpPr>
+            <a:spLocks noGrp="1"/>
+          </p:cNvSpPr>
+          <p:nvPr/>
+        </p:nvSpPr>
+        <p:spPr>
+          <a:xfrm>
+            <a:off x="4286250" y="1485900"/>
+            <a:ext cx="1028700" cy="228600"/>
+          </a:xfrm>
+          <a:prstGeom prst="rect">
+            <a:avLst/>
+          </a:prstGeom>
+          <a:noFill/>
+          <a:ln w="0">
+            <a:noFill/>
+            <a:prstDash val="solid"/>
+          </a:ln>
+        </p:spPr>
+        <p:txBody>
+          <a:bodyPr wrap="square" lIns="0" tIns="0" rIns="0" bIns="0" anchor="ctr">
+            <a:normAutofit/>
+          </a:bodyPr>
+          <a:lstStyle/>
+          <a:p>
+            <a:pPr marL="0" indent="0" algn="ctr">
+              <a:spcAft>
+                <a:spcPts val="0"/>
+              </a:spcAft>
+              <a:buNone/>
+              <a:defRPr sz="1050" b="1">
+                <a:solidFill>
+                  <a:srgbClr val="5B6F6A"/>
+                </a:solidFill>
+                <a:latin typeface="Aptos"/>
+                <a:ea typeface="Aptos"/>
+                <a:cs typeface="Aptos"/>
+              </a:defRPr>
+            </a:pPr>
+            <a:r>
+              <a:rPr sz="1050" b="1" i="0">
+                <a:solidFill>
+                  <a:srgbClr val="5B6F6A"/>
+                </a:solidFill>
+                <a:latin typeface="Aptos"/>
+                <a:ea typeface="Aptos"/>
+                <a:cs typeface="Aptos"/>
+              </a:rPr>
+              <a:t>W1</a:t>
+            </a:r>
+          </a:p>
+        </p:txBody>
+      </p:sp>
+      <p:sp>
+        <p:nvSpPr>
+          <p:cNvPr id="5" name="Rectangle 4">
+            <a:extLst>
+              <a:ext uri="{FF2B5EF4-FFF2-40B4-BE49-F238E27FC236}">
+                <a16:creationId xmlns:a16="http://schemas.microsoft.com/office/drawing/2014/main" id="{448B59A9-F171-4885-9112-2B2E44DEFC44}"/>
+              </a:ext>
+            </a:extLst>
+          </p:cNvPr>
+          <p:cNvSpPr>
+            <a:spLocks noGrp="1"/>
+          </p:cNvSpPr>
+          <p:nvPr/>
+        </p:nvSpPr>
+        <p:spPr>
+          <a:xfrm>
+            <a:off x="5467350" y="1485900"/>
+            <a:ext cx="1028700" cy="228600"/>
+          </a:xfrm>
+          <a:prstGeom prst="rect">
+            <a:avLst/>
+          </a:prstGeom>
+          <a:noFill/>
+          <a:ln w="0">
+            <a:noFill/>
+            <a:prstDash val="solid"/>
+          </a:ln>
+        </p:spPr>
+        <p:txBody>
+          <a:bodyPr wrap="square" lIns="0" tIns="0" rIns="0" bIns="0" anchor="ctr">
+            <a:normAutofit/>
+          </a:bodyPr>
+          <a:lstStyle/>
+          <a:p>
+            <a:pPr marL="0" indent="0" algn="ctr">
+              <a:spcAft>
+                <a:spcPts val="0"/>
+              </a:spcAft>
+              <a:buNone/>
+              <a:defRPr sz="1050" b="1">
+                <a:solidFill>
+                  <a:srgbClr val="5B6F6A"/>
+                </a:solidFill>
+                <a:latin typeface="Aptos"/>
+                <a:ea typeface="Aptos"/>
+                <a:cs typeface="Aptos"/>
+              </a:defRPr>
+            </a:pPr>
+            <a:r>
+              <a:rPr sz="1050" b="1" i="0">
+                <a:solidFill>
+                  <a:srgbClr val="5B6F6A"/>
+                </a:solidFill>
+                <a:latin typeface="Aptos"/>
+                <a:ea typeface="Aptos"/>
+                <a:cs typeface="Aptos"/>
+              </a:rPr>
+              <a:t>W2</a:t>
+            </a:r>
+          </a:p>
+        </p:txBody>
+      </p:sp>
+      <p:sp>
+        <p:nvSpPr>
+          <p:cNvPr id="6" name="Rectangle 5">
+            <a:extLst>
+              <a:ext uri="{FF2B5EF4-FFF2-40B4-BE49-F238E27FC236}">
+                <a16:creationId xmlns:a16="http://schemas.microsoft.com/office/drawing/2014/main" id="{076B9771-8E2F-43EF-93C9-7FF88C97696C}"/>
+              </a:ext>
+            </a:extLst>
+          </p:cNvPr>
+          <p:cNvSpPr>
+            <a:spLocks noGrp="1"/>
+          </p:cNvSpPr>
+          <p:nvPr/>
+        </p:nvSpPr>
+        <p:spPr>
+          <a:xfrm>
+            <a:off x="6648450" y="1485900"/>
+            <a:ext cx="1028700" cy="228600"/>
+          </a:xfrm>
+          <a:prstGeom prst="rect">
+            <a:avLst/>
+          </a:prstGeom>
+          <a:noFill/>
+          <a:ln w="0">
+            <a:noFill/>
+            <a:prstDash val="solid"/>
+          </a:ln>
+        </p:spPr>
+        <p:txBody>
+          <a:bodyPr wrap="square" lIns="0" tIns="0" rIns="0" bIns="0" anchor="ctr">
+            <a:normAutofit/>
+          </a:bodyPr>
+          <a:lstStyle/>
+          <a:p>
+            <a:pPr marL="0" indent="0" algn="ctr">
+              <a:spcAft>
+                <a:spcPts val="0"/>
+              </a:spcAft>
+              <a:buNone/>
+              <a:defRPr sz="1050" b="1">
+                <a:solidFill>
+                  <a:srgbClr val="5B6F6A"/>
+                </a:solidFill>
+                <a:latin typeface="Aptos"/>
+                <a:ea typeface="Aptos"/>
+                <a:cs typeface="Aptos"/>
+              </a:defRPr>
+            </a:pPr>
+            <a:r>
+              <a:rPr sz="1050" b="1" i="0">
+                <a:solidFill>
+                  <a:srgbClr val="5B6F6A"/>
+                </a:solidFill>
+                <a:latin typeface="Aptos"/>
+                <a:ea typeface="Aptos"/>
+                <a:cs typeface="Aptos"/>
+              </a:rPr>
+              <a:t>W3</a:t>
+            </a:r>
+          </a:p>
+        </p:txBody>
+      </p:sp>
+      <p:sp>
+        <p:nvSpPr>
+          <p:cNvPr id="7" name="Rectangle 6">
+            <a:extLst>
+              <a:ext uri="{FF2B5EF4-FFF2-40B4-BE49-F238E27FC236}">
+                <a16:creationId xmlns:a16="http://schemas.microsoft.com/office/drawing/2014/main" id="{D3A3C6BB-2617-4AF4-AD54-2BC1B55DA1E3}"/>
+              </a:ext>
+            </a:extLst>
+          </p:cNvPr>
+          <p:cNvSpPr>
+            <a:spLocks noGrp="1"/>
+          </p:cNvSpPr>
+          <p:nvPr/>
+        </p:nvSpPr>
+        <p:spPr>
+          <a:xfrm>
+            <a:off x="7829550" y="1485900"/>
+            <a:ext cx="1028700" cy="228600"/>
+          </a:xfrm>
+          <a:prstGeom prst="rect">
+            <a:avLst/>
+          </a:prstGeom>
+          <a:noFill/>
+          <a:ln w="0">
+            <a:noFill/>
+            <a:prstDash val="solid"/>
+          </a:ln>
+        </p:spPr>
+        <p:txBody>
+          <a:bodyPr wrap="square" lIns="0" tIns="0" rIns="0" bIns="0" anchor="ctr">
+            <a:normAutofit/>
+          </a:bodyPr>
+          <a:lstStyle/>
+          <a:p>
+            <a:pPr marL="0" indent="0" algn="ctr">
+              <a:spcAft>
+                <a:spcPts val="0"/>
+              </a:spcAft>
+              <a:buNone/>
+              <a:defRPr sz="1050" b="1">
+                <a:solidFill>
+                  <a:srgbClr val="5B6F6A"/>
+                </a:solidFill>
+                <a:latin typeface="Aptos"/>
+                <a:ea typeface="Aptos"/>
+                <a:cs typeface="Aptos"/>
+              </a:defRPr>
+            </a:pPr>
+            <a:r>
+              <a:rPr sz="1050" b="1" i="0">
+                <a:solidFill>
+                  <a:srgbClr val="5B6F6A"/>
+                </a:solidFill>
+                <a:latin typeface="Aptos"/>
+                <a:ea typeface="Aptos"/>
+                <a:cs typeface="Aptos"/>
+              </a:rPr>
+              <a:t>W4</a:t>
+            </a:r>
+          </a:p>
+        </p:txBody>
+      </p:sp>
+      <p:sp>
+        <p:nvSpPr>
+          <p:cNvPr id="8" name="Rectangle 7">
+            <a:extLst>
+              <a:ext uri="{FF2B5EF4-FFF2-40B4-BE49-F238E27FC236}">
+                <a16:creationId xmlns:a16="http://schemas.microsoft.com/office/drawing/2014/main" id="{F314FDCC-DD12-4E9F-88CE-E7F622534F4E}"/>
+              </a:ext>
+            </a:extLst>
+          </p:cNvPr>
+          <p:cNvSpPr>
+            <a:spLocks noGrp="1"/>
+          </p:cNvSpPr>
+          <p:nvPr/>
+        </p:nvSpPr>
+        <p:spPr>
+          <a:xfrm>
+            <a:off x="9010650" y="1485900"/>
+            <a:ext cx="1028700" cy="228600"/>
+          </a:xfrm>
+          <a:prstGeom prst="rect">
+            <a:avLst/>
+          </a:prstGeom>
+          <a:noFill/>
+          <a:ln w="0">
+            <a:noFill/>
+            <a:prstDash val="solid"/>
+          </a:ln>
+        </p:spPr>
+        <p:txBody>
+          <a:bodyPr wrap="square" lIns="0" tIns="0" rIns="0" bIns="0" anchor="ctr">
+            <a:normAutofit/>
+          </a:bodyPr>
+          <a:lstStyle/>
+          <a:p>
+            <a:pPr marL="0" indent="0" algn="ctr">
+              <a:spcAft>
+                <a:spcPts val="0"/>
+              </a:spcAft>
+              <a:buNone/>
+              <a:defRPr sz="1050" b="1">
+                <a:solidFill>
+                  <a:srgbClr val="5B6F6A"/>
+                </a:solidFill>
+                <a:latin typeface="Aptos"/>
+                <a:ea typeface="Aptos"/>
+                <a:cs typeface="Aptos"/>
+              </a:defRPr>
+            </a:pPr>
+            <a:r>
+              <a:rPr sz="1050" b="1" i="0">
+                <a:solidFill>
+                  <a:srgbClr val="5B6F6A"/>
+                </a:solidFill>
+                <a:latin typeface="Aptos"/>
+                <a:ea typeface="Aptos"/>
+                <a:cs typeface="Aptos"/>
+              </a:rPr>
+              <a:t>W5</a:t>
+            </a:r>
+          </a:p>
+        </p:txBody>
+      </p:sp>
+      <p:sp>
+        <p:nvSpPr>
+          <p:cNvPr id="9" name="Rectangle 8">
+            <a:extLst>
+              <a:ext uri="{FF2B5EF4-FFF2-40B4-BE49-F238E27FC236}">
+                <a16:creationId xmlns:a16="http://schemas.microsoft.com/office/drawing/2014/main" id="{16E2F162-5FD6-4800-837D-C4C22BBB3C7B}"/>
+              </a:ext>
+            </a:extLst>
+          </p:cNvPr>
+          <p:cNvSpPr>
+            <a:spLocks noGrp="1"/>
+          </p:cNvSpPr>
+          <p:nvPr/>
+        </p:nvSpPr>
+        <p:spPr>
+          <a:xfrm>
+            <a:off x="10306050" y="1485900"/>
+            <a:ext cx="1028700" cy="228600"/>
+          </a:xfrm>
+          <a:prstGeom prst="rect">
+            <a:avLst/>
+          </a:prstGeom>
+          <a:noFill/>
+          <a:ln w="0">
+            <a:noFill/>
+            <a:prstDash val="solid"/>
+          </a:ln>
+        </p:spPr>
+        <p:txBody>
+          <a:bodyPr wrap="square" lIns="0" tIns="0" rIns="0" bIns="0" anchor="ctr">
+            <a:normAutofit/>
+          </a:bodyPr>
+          <a:lstStyle/>
+          <a:p>
+            <a:pPr marL="0" indent="0" algn="ctr">
+              <a:spcAft>
+                <a:spcPts val="0"/>
+              </a:spcAft>
+              <a:buNone/>
+              <a:defRPr sz="1050" b="1">
+                <a:solidFill>
+                  <a:srgbClr val="5B6F6A"/>
+                </a:solidFill>
+                <a:latin typeface="Aptos"/>
+                <a:ea typeface="Aptos"/>
+                <a:cs typeface="Aptos"/>
+              </a:defRPr>
+            </a:pPr>
+            <a:r>
+              <a:rPr sz="1050" b="1" i="0">
+                <a:solidFill>
+                  <a:srgbClr val="5B6F6A"/>
+                </a:solidFill>
+                <a:latin typeface="Aptos"/>
+                <a:ea typeface="Aptos"/>
+                <a:cs typeface="Aptos"/>
+              </a:rPr>
+              <a:t>W6</a:t>
+            </a:r>
+          </a:p>
+        </p:txBody>
+      </p:sp>
+      <p:sp>
+        <p:nvSpPr>
+          <p:cNvPr id="10" name="Rounded Rectangle 9">
+            <a:extLst>
+              <a:ext uri="{FF2B5EF4-FFF2-40B4-BE49-F238E27FC236}">
+                <a16:creationId xmlns:a16="http://schemas.microsoft.com/office/drawing/2014/main" id="{68DCF7F5-881C-4FA9-BB53-654E0BF8E77A}"/>
+              </a:ext>
+            </a:extLst>
+          </p:cNvPr>
+          <p:cNvSpPr>
+            <a:spLocks noGrp="1"/>
+          </p:cNvSpPr>
+          <p:nvPr/>
+        </p:nvSpPr>
+        <p:spPr>
+          <a:xfrm>
+            <a:off x="4286250" y="2266950"/>
+            <a:ext cx="1028700" cy="628650"/>
+          </a:xfrm>
+          <a:prstGeom prst="roundRect">
+            <a:avLst>
+              <a:gd name="adj" fmla="val 9091"/>
+            </a:avLst>
+          </a:prstGeom>
+          <a:solidFill>
+            <a:srgbClr val="FFFFFF"/>
+          </a:solidFill>
+          <a:ln w="9525">
+            <a:solidFill>
+              <a:srgbClr val="087C72"/>
+            </a:solidFill>
+            <a:prstDash val="solid"/>
+          </a:ln>
+        </p:spPr>
+        <p:txBody>
+          <a:bodyPr wrap="square" lIns="57150" tIns="57150" rIns="57150" bIns="57150" anchor="ctr">
+            <a:normAutofit/>
+          </a:bodyPr>
+          <a:lstStyle/>
+          <a:p>
+            <a:pPr marL="0" indent="0" algn="ctr">
+              <a:spcAft>
+                <a:spcPts val="0"/>
+              </a:spcAft>
+              <a:buNone/>
+              <a:defRPr sz="1200" b="1">
+                <a:solidFill>
+                  <a:srgbClr val="132925"/>
+                </a:solidFill>
+                <a:latin typeface="Aptos"/>
+                <a:ea typeface="Aptos"/>
+                <a:cs typeface="Aptos"/>
+              </a:defRPr>
+            </a:pPr>
+            <a:r>
+              <a:rPr sz="1200" b="1" i="0">
+                <a:solidFill>
+                  <a:srgbClr val="132925"/>
+                </a:solidFill>
+                <a:latin typeface="Aptos"/>
+                <a:ea typeface="Aptos"/>
+                <a:cs typeface="Aptos"/>
+              </a:rPr>
+              <a:t>Recall
+Intake</a:t>
+            </a:r>
+          </a:p>
+        </p:txBody>
+      </p:sp>
+      <p:sp>
+        <p:nvSpPr>
+          <p:cNvPr id="11" name="Rounded Rectangle 10">
+            <a:extLst>
+              <a:ext uri="{FF2B5EF4-FFF2-40B4-BE49-F238E27FC236}">
+                <a16:creationId xmlns:a16="http://schemas.microsoft.com/office/drawing/2014/main" id="{4F83EC5C-7D46-4A2B-940C-CE3E71AB943D}"/>
+              </a:ext>
+            </a:extLst>
+          </p:cNvPr>
+          <p:cNvSpPr>
+            <a:spLocks noGrp="1"/>
+          </p:cNvSpPr>
+          <p:nvPr/>
+        </p:nvSpPr>
+        <p:spPr>
+          <a:xfrm>
+            <a:off x="5467350" y="2266950"/>
+            <a:ext cx="1028700" cy="628650"/>
+          </a:xfrm>
+          <a:prstGeom prst="roundRect">
+            <a:avLst>
+              <a:gd name="adj" fmla="val 9091"/>
+            </a:avLst>
+          </a:prstGeom>
+          <a:solidFill>
+            <a:srgbClr val="FFFFFF"/>
+          </a:solidFill>
+          <a:ln w="9525">
+            <a:solidFill>
+              <a:srgbClr val="087C72"/>
+            </a:solidFill>
+            <a:prstDash val="solid"/>
+          </a:ln>
+        </p:spPr>
+        <p:txBody>
+          <a:bodyPr wrap="square" lIns="57150" tIns="57150" rIns="57150" bIns="57150" anchor="ctr">
+            <a:normAutofit/>
+          </a:bodyPr>
+          <a:lstStyle/>
+          <a:p>
+            <a:pPr marL="0" indent="0" algn="ctr">
+              <a:spcAft>
+                <a:spcPts val="0"/>
+              </a:spcAft>
+              <a:buNone/>
+              <a:defRPr sz="1200" b="1">
+                <a:solidFill>
+                  <a:srgbClr val="132925"/>
+                </a:solidFill>
+                <a:latin typeface="Aptos"/>
+                <a:ea typeface="Aptos"/>
+                <a:cs typeface="Aptos"/>
+              </a:defRPr>
+            </a:pPr>
+            <a:r>
+              <a:rPr sz="1200" b="1" i="0">
+                <a:solidFill>
+                  <a:srgbClr val="132925"/>
+                </a:solidFill>
+                <a:latin typeface="Aptos"/>
+                <a:ea typeface="Aptos"/>
+                <a:cs typeface="Aptos"/>
+              </a:rPr>
+              <a:t>Document
+Extraction</a:t>
+            </a:r>
+          </a:p>
+        </p:txBody>
+      </p:sp>
+      <p:sp>
+        <p:nvSpPr>
+          <p:cNvPr id="12" name="Rounded Rectangle 11">
+            <a:extLst>
+              <a:ext uri="{FF2B5EF4-FFF2-40B4-BE49-F238E27FC236}">
+                <a16:creationId xmlns:a16="http://schemas.microsoft.com/office/drawing/2014/main" id="{AC608A92-6048-4570-87D8-8F47F9EA861D}"/>
+              </a:ext>
+            </a:extLst>
+          </p:cNvPr>
+          <p:cNvSpPr>
+            <a:spLocks noGrp="1"/>
+          </p:cNvSpPr>
+          <p:nvPr/>
+        </p:nvSpPr>
+        <p:spPr>
+          <a:xfrm>
+            <a:off x="6648450" y="1924050"/>
+            <a:ext cx="1028700" cy="552450"/>
+          </a:xfrm>
+          <a:prstGeom prst="roundRect">
+            <a:avLst>
+              <a:gd name="adj" fmla="val 10345"/>
+            </a:avLst>
+          </a:prstGeom>
+          <a:solidFill>
+            <a:srgbClr val="FFFFFF"/>
+          </a:solidFill>
+          <a:ln w="9525">
+            <a:solidFill>
+              <a:srgbClr val="087C72"/>
+            </a:solidFill>
+            <a:prstDash val="solid"/>
+          </a:ln>
+        </p:spPr>
+        <p:txBody>
+          <a:bodyPr wrap="square" lIns="57150" tIns="57150" rIns="57150" bIns="57150" anchor="ctr">
+            <a:normAutofit/>
+          </a:bodyPr>
+          <a:lstStyle/>
+          <a:p>
+            <a:pPr marL="0" indent="0" algn="ctr">
+              <a:spcAft>
+                <a:spcPts val="0"/>
+              </a:spcAft>
+              <a:buNone/>
+              <a:defRPr sz="1125" b="1">
+                <a:solidFill>
+                  <a:srgbClr val="132925"/>
+                </a:solidFill>
+                <a:latin typeface="Aptos"/>
+                <a:ea typeface="Aptos"/>
+                <a:cs typeface="Aptos"/>
+              </a:defRPr>
+            </a:pPr>
+            <a:r>
+              <a:rPr sz="1125" b="1" i="0">
+                <a:solidFill>
+                  <a:srgbClr val="132925"/>
+                </a:solidFill>
+                <a:latin typeface="Aptos"/>
+                <a:ea typeface="Aptos"/>
+                <a:cs typeface="Aptos"/>
+              </a:rPr>
+              <a:t>Inventory
+Matching</a:t>
+            </a:r>
+          </a:p>
+        </p:txBody>
+      </p:sp>
+      <p:sp>
+        <p:nvSpPr>
+          <p:cNvPr id="13" name="Rounded Rectangle 12">
+            <a:extLst>
+              <a:ext uri="{FF2B5EF4-FFF2-40B4-BE49-F238E27FC236}">
+                <a16:creationId xmlns:a16="http://schemas.microsoft.com/office/drawing/2014/main" id="{802F5D04-2040-4DD5-8D55-3F83CFD34CEA}"/>
+              </a:ext>
+            </a:extLst>
+          </p:cNvPr>
+          <p:cNvSpPr>
+            <a:spLocks noGrp="1"/>
+          </p:cNvSpPr>
+          <p:nvPr/>
+        </p:nvSpPr>
+        <p:spPr>
+          <a:xfrm>
+            <a:off x="6648450" y="2686050"/>
+            <a:ext cx="1028700" cy="552450"/>
+          </a:xfrm>
+          <a:prstGeom prst="roundRect">
+            <a:avLst>
+              <a:gd name="adj" fmla="val 10345"/>
+            </a:avLst>
+          </a:prstGeom>
+          <a:solidFill>
+            <a:srgbClr val="FFFFFF"/>
+          </a:solidFill>
+          <a:ln w="9525">
+            <a:solidFill>
+              <a:srgbClr val="C47A00"/>
+            </a:solidFill>
+            <a:prstDash val="solid"/>
+          </a:ln>
+        </p:spPr>
+        <p:txBody>
+          <a:bodyPr wrap="square" lIns="57150" tIns="57150" rIns="57150" bIns="57150" anchor="ctr">
+            <a:normAutofit/>
+          </a:bodyPr>
+          <a:lstStyle/>
+          <a:p>
+            <a:pPr marL="0" indent="0" algn="ctr">
+              <a:spcAft>
+                <a:spcPts val="0"/>
+              </a:spcAft>
+              <a:buNone/>
+              <a:defRPr sz="1125" b="1">
+                <a:solidFill>
+                  <a:srgbClr val="132925"/>
+                </a:solidFill>
+                <a:latin typeface="Aptos"/>
+                <a:ea typeface="Aptos"/>
+                <a:cs typeface="Aptos"/>
+              </a:defRPr>
+            </a:pPr>
+            <a:r>
+              <a:rPr sz="1125" b="1" i="0">
+                <a:solidFill>
+                  <a:srgbClr val="132925"/>
+                </a:solidFill>
+                <a:latin typeface="Aptos"/>
+                <a:ea typeface="Aptos"/>
+                <a:cs typeface="Aptos"/>
+              </a:rPr>
+              <a:t>Shelf
+Vision</a:t>
+            </a:r>
+          </a:p>
+        </p:txBody>
+      </p:sp>
+      <p:sp>
+        <p:nvSpPr>
+          <p:cNvPr id="14" name="Rounded Rectangle 13">
+            <a:extLst>
+              <a:ext uri="{FF2B5EF4-FFF2-40B4-BE49-F238E27FC236}">
+                <a16:creationId xmlns:a16="http://schemas.microsoft.com/office/drawing/2014/main" id="{3B2E78B3-8F8B-4049-BCAF-1E40DCFF6C12}"/>
+              </a:ext>
+            </a:extLst>
+          </p:cNvPr>
+          <p:cNvSpPr>
+            <a:spLocks noGrp="1"/>
+          </p:cNvSpPr>
+          <p:nvPr/>
+        </p:nvSpPr>
+        <p:spPr>
+          <a:xfrm>
+            <a:off x="7829550" y="1924050"/>
+            <a:ext cx="1028700" cy="552450"/>
+          </a:xfrm>
+          <a:prstGeom prst="roundRect">
+            <a:avLst>
+              <a:gd name="adj" fmla="val 10345"/>
+            </a:avLst>
+          </a:prstGeom>
+          <a:solidFill>
+            <a:srgbClr val="FFFFFF"/>
+          </a:solidFill>
+          <a:ln w="9525">
+            <a:solidFill>
+              <a:srgbClr val="B42318"/>
+            </a:solidFill>
+            <a:prstDash val="solid"/>
+          </a:ln>
+        </p:spPr>
+        <p:txBody>
+          <a:bodyPr wrap="square" lIns="57150" tIns="57150" rIns="57150" bIns="57150" anchor="ctr">
+            <a:normAutofit/>
+          </a:bodyPr>
+          <a:lstStyle/>
+          <a:p>
+            <a:pPr marL="0" indent="0" algn="ctr">
+              <a:spcAft>
+                <a:spcPts val="0"/>
+              </a:spcAft>
+              <a:buNone/>
+              <a:defRPr sz="1125" b="1">
+                <a:solidFill>
+                  <a:srgbClr val="132925"/>
+                </a:solidFill>
+                <a:latin typeface="Aptos"/>
+                <a:ea typeface="Aptos"/>
+                <a:cs typeface="Aptos"/>
+              </a:defRPr>
+            </a:pPr>
+            <a:r>
+              <a:rPr sz="1125" b="1" i="0">
+                <a:solidFill>
+                  <a:srgbClr val="132925"/>
+                </a:solidFill>
+                <a:latin typeface="Aptos"/>
+                <a:ea typeface="Aptos"/>
+                <a:cs typeface="Aptos"/>
+              </a:rPr>
+              <a:t>Risk
+Scoring</a:t>
+            </a:r>
+          </a:p>
+        </p:txBody>
+      </p:sp>
+      <p:sp>
+        <p:nvSpPr>
+          <p:cNvPr id="15" name="Rounded Rectangle 14">
+            <a:extLst>
+              <a:ext uri="{FF2B5EF4-FFF2-40B4-BE49-F238E27FC236}">
+                <a16:creationId xmlns:a16="http://schemas.microsoft.com/office/drawing/2014/main" id="{B664A8C3-2A39-4ADB-971F-CE6FB368DDDD}"/>
+              </a:ext>
+            </a:extLst>
+          </p:cNvPr>
+          <p:cNvSpPr>
+            <a:spLocks noGrp="1"/>
+          </p:cNvSpPr>
+          <p:nvPr/>
+        </p:nvSpPr>
+        <p:spPr>
+          <a:xfrm>
+            <a:off x="7829550" y="2686050"/>
+            <a:ext cx="1028700" cy="552450"/>
+          </a:xfrm>
+          <a:prstGeom prst="roundRect">
+            <a:avLst>
+              <a:gd name="adj" fmla="val 10345"/>
+            </a:avLst>
+          </a:prstGeom>
+          <a:solidFill>
+            <a:srgbClr val="FFFFFF"/>
+          </a:solidFill>
+          <a:ln w="9525">
+            <a:solidFill>
+              <a:srgbClr val="087C72"/>
+            </a:solidFill>
+            <a:prstDash val="solid"/>
+          </a:ln>
+        </p:spPr>
+        <p:txBody>
+          <a:bodyPr wrap="square" lIns="57150" tIns="57150" rIns="57150" bIns="57150" anchor="ctr">
+            <a:normAutofit/>
+          </a:bodyPr>
+          <a:lstStyle/>
+          <a:p>
+            <a:pPr marL="0" indent="0" algn="ctr">
+              <a:spcAft>
+                <a:spcPts val="0"/>
+              </a:spcAft>
+              <a:buNone/>
+              <a:defRPr sz="1125" b="1">
+                <a:solidFill>
+                  <a:srgbClr val="132925"/>
+                </a:solidFill>
+                <a:latin typeface="Aptos"/>
+                <a:ea typeface="Aptos"/>
+                <a:cs typeface="Aptos"/>
+              </a:defRPr>
+            </a:pPr>
+            <a:r>
+              <a:rPr sz="1125" b="1" i="0">
+                <a:solidFill>
+                  <a:srgbClr val="132925"/>
+                </a:solidFill>
+                <a:latin typeface="Aptos"/>
+                <a:ea typeface="Aptos"/>
+                <a:cs typeface="Aptos"/>
+              </a:rPr>
+              <a:t>Memory</a:t>
+            </a:r>
+          </a:p>
+        </p:txBody>
+      </p:sp>
+      <p:sp>
+        <p:nvSpPr>
+          <p:cNvPr id="16" name="Rounded Rectangle 15">
+            <a:extLst>
+              <a:ext uri="{FF2B5EF4-FFF2-40B4-BE49-F238E27FC236}">
+                <a16:creationId xmlns:a16="http://schemas.microsoft.com/office/drawing/2014/main" id="{0EC09146-F730-4511-B356-1196A87315C4}"/>
+              </a:ext>
+            </a:extLst>
+          </p:cNvPr>
+          <p:cNvSpPr>
+            <a:spLocks noGrp="1"/>
+          </p:cNvSpPr>
+          <p:nvPr/>
+        </p:nvSpPr>
+        <p:spPr>
+          <a:xfrm>
+            <a:off x="9010650" y="1924050"/>
+            <a:ext cx="1028700" cy="552450"/>
+          </a:xfrm>
+          <a:prstGeom prst="roundRect">
+            <a:avLst>
+              <a:gd name="adj" fmla="val 10345"/>
+            </a:avLst>
+          </a:prstGeom>
+          <a:solidFill>
+            <a:srgbClr val="FFFFFF"/>
+          </a:solidFill>
+          <a:ln w="9525">
+            <a:solidFill>
+              <a:srgbClr val="087C72"/>
+            </a:solidFill>
+            <a:prstDash val="solid"/>
+          </a:ln>
+        </p:spPr>
+        <p:txBody>
+          <a:bodyPr wrap="square" lIns="57150" tIns="57150" rIns="57150" bIns="57150" anchor="ctr">
+            <a:normAutofit/>
+          </a:bodyPr>
+          <a:lstStyle/>
+          <a:p>
+            <a:pPr marL="0" indent="0" algn="ctr">
+              <a:spcAft>
+                <a:spcPts val="0"/>
+              </a:spcAft>
+              <a:buNone/>
+              <a:defRPr sz="1125" b="1">
+                <a:solidFill>
+                  <a:srgbClr val="132925"/>
+                </a:solidFill>
+                <a:latin typeface="Aptos"/>
+                <a:ea typeface="Aptos"/>
+                <a:cs typeface="Aptos"/>
+              </a:defRPr>
+            </a:pPr>
+            <a:r>
+              <a:rPr sz="1125" b="1" i="0">
+                <a:solidFill>
+                  <a:srgbClr val="132925"/>
+                </a:solidFill>
+                <a:latin typeface="Aptos"/>
+                <a:ea typeface="Aptos"/>
+                <a:cs typeface="Aptos"/>
+              </a:rPr>
+              <a:t>Operations
+Task</a:t>
+            </a:r>
+          </a:p>
+        </p:txBody>
+      </p:sp>
+      <p:sp>
+        <p:nvSpPr>
+          <p:cNvPr id="17" name="Rounded Rectangle 16">
+            <a:extLst>
+              <a:ext uri="{FF2B5EF4-FFF2-40B4-BE49-F238E27FC236}">
+                <a16:creationId xmlns:a16="http://schemas.microsoft.com/office/drawing/2014/main" id="{34C5F984-1002-4636-8C3E-DD368301D16A}"/>
+              </a:ext>
+            </a:extLst>
+          </p:cNvPr>
+          <p:cNvSpPr>
+            <a:spLocks noGrp="1"/>
+          </p:cNvSpPr>
+          <p:nvPr/>
+        </p:nvSpPr>
+        <p:spPr>
+          <a:xfrm>
+            <a:off x="9010650" y="2686050"/>
+            <a:ext cx="1162050" cy="552450"/>
+          </a:xfrm>
+          <a:prstGeom prst="roundRect">
+            <a:avLst>
+              <a:gd name="adj" fmla="val 10345"/>
+            </a:avLst>
+          </a:prstGeom>
+          <a:solidFill>
+            <a:srgbClr val="FFFFFF"/>
+          </a:solidFill>
+          <a:ln w="9525">
+            <a:solidFill>
+              <a:srgbClr val="087C72"/>
+            </a:solidFill>
+            <a:prstDash val="solid"/>
+          </a:ln>
+        </p:spPr>
+        <p:txBody>
+          <a:bodyPr wrap="square" lIns="57150" tIns="57150" rIns="57150" bIns="57150" anchor="ctr">
+            <a:normAutofit/>
+          </a:bodyPr>
+          <a:lstStyle/>
+          <a:p>
+            <a:pPr marL="0" indent="0" algn="ctr">
+              <a:spcAft>
+                <a:spcPts val="0"/>
+              </a:spcAft>
+              <a:buNone/>
+              <a:defRPr sz="1050" b="1">
+                <a:solidFill>
+                  <a:srgbClr val="132925"/>
+                </a:solidFill>
+                <a:latin typeface="Aptos"/>
+                <a:ea typeface="Aptos"/>
+                <a:cs typeface="Aptos"/>
+              </a:defRPr>
+            </a:pPr>
+            <a:r>
+              <a:rPr sz="1050" b="1" i="0">
+                <a:solidFill>
+                  <a:srgbClr val="132925"/>
+                </a:solidFill>
+                <a:latin typeface="Aptos"/>
+                <a:ea typeface="Aptos"/>
+                <a:cs typeface="Aptos"/>
+              </a:rPr>
+              <a:t>Communications</a:t>
+            </a:r>
+          </a:p>
+        </p:txBody>
+      </p:sp>
+      <p:sp>
+        <p:nvSpPr>
+          <p:cNvPr id="18" name="Rounded Rectangle 17">
+            <a:extLst>
+              <a:ext uri="{FF2B5EF4-FFF2-40B4-BE49-F238E27FC236}">
+                <a16:creationId xmlns:a16="http://schemas.microsoft.com/office/drawing/2014/main" id="{8ADCE7A4-E669-4DB8-879D-3310E39878B7}"/>
+              </a:ext>
+            </a:extLst>
+          </p:cNvPr>
+          <p:cNvSpPr>
+            <a:spLocks noGrp="1"/>
+          </p:cNvSpPr>
+          <p:nvPr/>
+        </p:nvSpPr>
+        <p:spPr>
+          <a:xfrm>
+            <a:off x="10306050" y="2266950"/>
+            <a:ext cx="1028700" cy="628650"/>
+          </a:xfrm>
+          <a:prstGeom prst="roundRect">
+            <a:avLst>
+              <a:gd name="adj" fmla="val 9091"/>
+            </a:avLst>
+          </a:prstGeom>
+          <a:solidFill>
+            <a:srgbClr val="0B3D38"/>
+          </a:solidFill>
+          <a:ln w="9525">
+            <a:solidFill>
+              <a:srgbClr val="0B3D38"/>
+            </a:solidFill>
+            <a:prstDash val="solid"/>
+          </a:ln>
+        </p:spPr>
+        <p:txBody>
+          <a:bodyPr wrap="square" lIns="57150" tIns="57150" rIns="57150" bIns="57150" anchor="ctr">
+            <a:normAutofit/>
+          </a:bodyPr>
+          <a:lstStyle/>
+          <a:p>
+            <a:pPr marL="0" indent="0" algn="ctr">
+              <a:spcAft>
+                <a:spcPts val="0"/>
+              </a:spcAft>
+              <a:buNone/>
+              <a:defRPr sz="1125" b="1">
+                <a:solidFill>
+                  <a:srgbClr val="FFFFFF"/>
+                </a:solidFill>
+                <a:latin typeface="Aptos"/>
+                <a:ea typeface="Aptos"/>
+                <a:cs typeface="Aptos"/>
+              </a:defRPr>
+            </a:pPr>
+            <a:r>
+              <a:rPr sz="1125" b="1" i="0">
+                <a:solidFill>
+                  <a:srgbClr val="FFFFFF"/>
+                </a:solidFill>
+                <a:latin typeface="Aptos"/>
+                <a:ea typeface="Aptos"/>
+                <a:cs typeface="Aptos"/>
+              </a:rPr>
+              <a:t>Compliance
+Evidence</a:t>
+            </a:r>
+          </a:p>
+        </p:txBody>
+      </p:sp>
+      <p:cxnSp>
+        <p:nvCxnSpPr>
+          <p:cNvPr id="52" name="Straight Arrow Connector 51"/>
+          <p:cNvCxnSpPr>
+            <a:stCxn id="10" idx="3"/>
+            <a:endCxn id="11" idx="1"/>
+          </p:cNvCxnSpPr>
+          <p:nvPr/>
+        </p:nvCxnSpPr>
+        <p:spPr>
+          <a:xfrm>
+            <a:off x="5314950" y="2581275"/>
+            <a:ext cx="152400" cy="0"/>
+          </a:xfrm>
+          <a:prstGeom prst="straightConnector1">
+            <a:avLst/>
+          </a:prstGeom>
+          <a:ln w="19050">
+            <a:solidFill>
+              <a:srgbClr val="D6E3DF"/>
+            </a:solidFill>
+            <a:prstDash val="solid"/>
+            <a:headEnd type="none" w="med" len="med"/>
+            <a:tailEnd type="arrow" w="sm" len="sm"/>
+          </a:ln>
+        </p:spPr>
+      </p:cxnSp>
+      <p:cxnSp>
+        <p:nvCxnSpPr>
+          <p:cNvPr id="53" name="Elbow Connector 52"/>
+          <p:cNvCxnSpPr>
+            <a:stCxn id="11" idx="3"/>
+            <a:endCxn id="12" idx="1"/>
+          </p:cNvCxnSpPr>
+          <p:nvPr/>
+        </p:nvCxnSpPr>
+        <p:spPr>
+          <a:xfrm flipV="1">
+            <a:off x="6496050" y="2200275"/>
+            <a:ext cx="152400" cy="381000"/>
+          </a:xfrm>
+          <a:prstGeom prst="bentConnector3">
+            <a:avLst>
+              <a:gd name="adj1" fmla="val 50000"/>
+            </a:avLst>
+          </a:prstGeom>
+          <a:ln w="19050">
+            <a:solidFill>
+              <a:srgbClr val="D6E3DF"/>
+            </a:solidFill>
+            <a:prstDash val="solid"/>
+            <a:headEnd type="none" w="med" len="med"/>
+            <a:tailEnd type="arrow" w="sm" len="sm"/>
+          </a:ln>
+        </p:spPr>
+      </p:cxnSp>
+      <p:cxnSp>
+        <p:nvCxnSpPr>
+          <p:cNvPr id="54" name="Elbow Connector 53"/>
+          <p:cNvCxnSpPr>
+            <a:stCxn id="11" idx="3"/>
+            <a:endCxn id="13" idx="1"/>
+          </p:cNvCxnSpPr>
+          <p:nvPr/>
+        </p:nvCxnSpPr>
+        <p:spPr>
+          <a:xfrm>
+            <a:off x="6496050" y="2581275"/>
+            <a:ext cx="152400" cy="381000"/>
+          </a:xfrm>
+          <a:prstGeom prst="bentConnector3">
+            <a:avLst>
+              <a:gd name="adj1" fmla="val 50000"/>
+            </a:avLst>
+          </a:prstGeom>
+          <a:ln w="19050">
+            <a:solidFill>
+              <a:srgbClr val="D6E3DF"/>
+            </a:solidFill>
+            <a:prstDash val="solid"/>
+            <a:headEnd type="none" w="med" len="med"/>
+            <a:tailEnd type="arrow" w="sm" len="sm"/>
+          </a:ln>
+        </p:spPr>
+      </p:cxnSp>
+      <p:cxnSp>
+        <p:nvCxnSpPr>
+          <p:cNvPr id="55" name="Straight Arrow Connector 54"/>
+          <p:cNvCxnSpPr>
+            <a:stCxn id="12" idx="3"/>
+            <a:endCxn id="14" idx="1"/>
+          </p:cNvCxnSpPr>
+          <p:nvPr/>
+        </p:nvCxnSpPr>
+        <p:spPr>
+          <a:xfrm>
+            <a:off x="7677150" y="2200275"/>
+            <a:ext cx="152400" cy="0"/>
+          </a:xfrm>
+          <a:prstGeom prst="straightConnector1">
+            <a:avLst/>
+          </a:prstGeom>
+          <a:ln w="19050">
+            <a:solidFill>
+              <a:srgbClr val="D6E3DF"/>
+            </a:solidFill>
+            <a:prstDash val="solid"/>
+            <a:headEnd type="none" w="med" len="med"/>
+            <a:tailEnd type="arrow" w="sm" len="sm"/>
+          </a:ln>
+        </p:spPr>
+      </p:cxnSp>
+      <p:cxnSp>
+        <p:nvCxnSpPr>
+          <p:cNvPr id="56" name="Elbow Connector 55"/>
+          <p:cNvCxnSpPr>
+            <a:stCxn id="12" idx="3"/>
+            <a:endCxn id="15" idx="1"/>
+          </p:cNvCxnSpPr>
+          <p:nvPr/>
+        </p:nvCxnSpPr>
+        <p:spPr>
+          <a:xfrm>
+            <a:off x="7677150" y="2200275"/>
+            <a:ext cx="152400" cy="762000"/>
+          </a:xfrm>
+          <a:prstGeom prst="bentConnector3">
+            <a:avLst>
+              <a:gd name="adj1" fmla="val 50000"/>
+            </a:avLst>
+          </a:prstGeom>
+          <a:ln w="19050">
+            <a:solidFill>
+              <a:srgbClr val="D6E3DF"/>
+            </a:solidFill>
+            <a:prstDash val="solid"/>
+            <a:headEnd type="none" w="med" len="med"/>
+            <a:tailEnd type="arrow" w="sm" len="sm"/>
+          </a:ln>
+        </p:spPr>
+      </p:cxnSp>
+      <p:cxnSp>
+        <p:nvCxnSpPr>
+          <p:cNvPr id="57" name="Elbow Connector 56"/>
+          <p:cNvCxnSpPr>
+            <a:stCxn id="13" idx="3"/>
+            <a:endCxn id="14" idx="1"/>
+          </p:cNvCxnSpPr>
+          <p:nvPr/>
+        </p:nvCxnSpPr>
+        <p:spPr>
+          <a:xfrm flipV="1">
+            <a:off x="7677150" y="2200275"/>
+            <a:ext cx="152400" cy="762000"/>
+          </a:xfrm>
+          <a:prstGeom prst="bentConnector3">
+            <a:avLst>
+              <a:gd name="adj1" fmla="val 50000"/>
+            </a:avLst>
+          </a:prstGeom>
+          <a:ln w="19050">
+            <a:solidFill>
+              <a:srgbClr val="D7B56D"/>
+            </a:solidFill>
+            <a:prstDash val="solid"/>
+            <a:headEnd type="none" w="med" len="med"/>
+            <a:tailEnd type="arrow" w="sm" len="sm"/>
+          </a:ln>
+        </p:spPr>
+      </p:cxnSp>
+      <p:cxnSp>
+        <p:nvCxnSpPr>
+          <p:cNvPr id="58" name="Straight Arrow Connector 57"/>
+          <p:cNvCxnSpPr>
+            <a:stCxn id="14" idx="3"/>
+            <a:endCxn id="16" idx="1"/>
+          </p:cNvCxnSpPr>
+          <p:nvPr/>
+        </p:nvCxnSpPr>
+        <p:spPr>
+          <a:xfrm>
+            <a:off x="8858250" y="2200275"/>
+            <a:ext cx="152400" cy="0"/>
+          </a:xfrm>
+          <a:prstGeom prst="straightConnector1">
+            <a:avLst/>
+          </a:prstGeom>
+          <a:ln w="19050">
+            <a:solidFill>
+              <a:srgbClr val="D6E3DF"/>
+            </a:solidFill>
+            <a:prstDash val="solid"/>
+            <a:headEnd type="none" w="med" len="med"/>
+            <a:tailEnd type="arrow" w="sm" len="sm"/>
+          </a:ln>
+        </p:spPr>
+      </p:cxnSp>
+      <p:cxnSp>
+        <p:nvCxnSpPr>
+          <p:cNvPr id="59" name="Elbow Connector 58"/>
+          <p:cNvCxnSpPr>
+            <a:stCxn id="14" idx="3"/>
+            <a:endCxn id="17" idx="1"/>
+          </p:cNvCxnSpPr>
+          <p:nvPr/>
+        </p:nvCxnSpPr>
+        <p:spPr>
+          <a:xfrm>
+            <a:off x="8858250" y="2200275"/>
+            <a:ext cx="152400" cy="762000"/>
+          </a:xfrm>
+          <a:prstGeom prst="bentConnector3">
+            <a:avLst>
+              <a:gd name="adj1" fmla="val 50000"/>
+            </a:avLst>
+          </a:prstGeom>
+          <a:ln w="19050">
+            <a:solidFill>
+              <a:srgbClr val="D6E3DF"/>
+            </a:solidFill>
+            <a:prstDash val="solid"/>
+            <a:headEnd type="none" w="med" len="med"/>
+            <a:tailEnd type="arrow" w="sm" len="sm"/>
+          </a:ln>
+        </p:spPr>
+      </p:cxnSp>
+      <p:cxnSp>
+        <p:nvCxnSpPr>
+          <p:cNvPr id="60" name="Elbow Connector 59"/>
+          <p:cNvCxnSpPr>
+            <a:stCxn id="15" idx="3"/>
+            <a:endCxn id="16" idx="1"/>
+          </p:cNvCxnSpPr>
+          <p:nvPr/>
+        </p:nvCxnSpPr>
+        <p:spPr>
+          <a:xfrm flipV="1">
+            <a:off x="8858250" y="2200275"/>
+            <a:ext cx="152400" cy="762000"/>
+          </a:xfrm>
+          <a:prstGeom prst="bentConnector3">
+            <a:avLst>
+              <a:gd name="adj1" fmla="val 50000"/>
+            </a:avLst>
+          </a:prstGeom>
+          <a:ln w="19050">
+            <a:solidFill>
+              <a:srgbClr val="D6E3DF"/>
+            </a:solidFill>
+            <a:prstDash val="solid"/>
+            <a:headEnd type="none" w="med" len="med"/>
+            <a:tailEnd type="arrow" w="sm" len="sm"/>
+          </a:ln>
+        </p:spPr>
+      </p:cxnSp>
+      <p:cxnSp>
+        <p:nvCxnSpPr>
+          <p:cNvPr id="61" name="Straight Arrow Connector 60"/>
+          <p:cNvCxnSpPr>
+            <a:stCxn id="15" idx="3"/>
+            <a:endCxn id="17" idx="1"/>
+          </p:cNvCxnSpPr>
+          <p:nvPr/>
+        </p:nvCxnSpPr>
+        <p:spPr>
+          <a:xfrm>
+            <a:off x="8858250" y="2962275"/>
+            <a:ext cx="152400" cy="0"/>
+          </a:xfrm>
+          <a:prstGeom prst="straightConnector1">
+            <a:avLst/>
+          </a:prstGeom>
+          <a:ln w="19050">
+            <a:solidFill>
+              <a:srgbClr val="D6E3DF"/>
+            </a:solidFill>
+            <a:prstDash val="solid"/>
+            <a:headEnd type="none" w="med" len="med"/>
+            <a:tailEnd type="arrow" w="sm" len="sm"/>
+          </a:ln>
+        </p:spPr>
+      </p:cxnSp>
+      <p:cxnSp>
+        <p:nvCxnSpPr>
+          <p:cNvPr id="62" name="Elbow Connector 61"/>
+          <p:cNvCxnSpPr>
+            <a:stCxn id="16" idx="3"/>
+            <a:endCxn id="18" idx="1"/>
+          </p:cNvCxnSpPr>
+          <p:nvPr/>
+        </p:nvCxnSpPr>
+        <p:spPr>
+          <a:xfrm>
+            <a:off x="10039350" y="2200275"/>
+            <a:ext cx="266700" cy="381000"/>
+          </a:xfrm>
+          <a:prstGeom prst="bentConnector3">
+            <a:avLst>
+              <a:gd name="adj1" fmla="val 50000"/>
+            </a:avLst>
+          </a:prstGeom>
+          <a:ln w="19050">
+            <a:solidFill>
+              <a:srgbClr val="D6E3DF"/>
+            </a:solidFill>
+            <a:prstDash val="solid"/>
+            <a:headEnd type="none" w="med" len="med"/>
+            <a:tailEnd type="arrow" w="sm" len="sm"/>
+          </a:ln>
+        </p:spPr>
+      </p:cxnSp>
+      <p:cxnSp>
+        <p:nvCxnSpPr>
+          <p:cNvPr id="63" name="Elbow Connector 62"/>
+          <p:cNvCxnSpPr>
+            <a:stCxn id="17" idx="3"/>
+            <a:endCxn id="18" idx="1"/>
+          </p:cNvCxnSpPr>
+          <p:nvPr/>
+        </p:nvCxnSpPr>
+        <p:spPr>
+          <a:xfrm flipV="1">
+            <a:off x="10172700" y="2581275"/>
+            <a:ext cx="133350" cy="381000"/>
+          </a:xfrm>
+          <a:prstGeom prst="bentConnector3">
+            <a:avLst>
+              <a:gd name="adj1" fmla="val 50000"/>
+            </a:avLst>
+          </a:prstGeom>
+          <a:ln w="19050">
+            <a:solidFill>
+              <a:srgbClr val="D6E3DF"/>
+            </a:solidFill>
+            <a:prstDash val="solid"/>
+            <a:headEnd type="none" w="med" len="med"/>
+            <a:tailEnd type="arrow" w="sm" len="sm"/>
+          </a:ln>
+        </p:spPr>
+      </p:cxnSp>
+      <p:sp>
+        <p:nvSpPr>
+          <p:cNvPr id="31" name="Rounded Rectangle 30">
+            <a:extLst>
+              <a:ext uri="{FF2B5EF4-FFF2-40B4-BE49-F238E27FC236}">
+                <a16:creationId xmlns:a16="http://schemas.microsoft.com/office/drawing/2014/main" id="{2C39C159-3EA0-4B5C-A6D5-3C34CEB85E64}"/>
+              </a:ext>
+            </a:extLst>
+          </p:cNvPr>
+          <p:cNvSpPr>
+            <a:spLocks noGrp="1"/>
+          </p:cNvSpPr>
+          <p:nvPr/>
+        </p:nvSpPr>
+        <p:spPr>
+          <a:xfrm>
+            <a:off x="4286250" y="3543300"/>
+            <a:ext cx="1866900" cy="285750"/>
+          </a:xfrm>
+          <a:prstGeom prst="roundRect">
+            <a:avLst>
+              <a:gd name="adj" fmla="val 20000"/>
+            </a:avLst>
+          </a:prstGeom>
+          <a:solidFill>
+            <a:srgbClr val="E6F3F1"/>
+          </a:solidFill>
+          <a:ln w="9525">
+            <a:solidFill>
+              <a:srgbClr val="E6F3F1"/>
+            </a:solidFill>
+            <a:prstDash val="solid"/>
+          </a:ln>
+        </p:spPr>
+        <p:txBody>
+          <a:bodyPr/>
+          <a:lstStyle/>
+          <a:p>
+            <a:endParaRPr lang="en-US"/>
+          </a:p>
+        </p:txBody>
+      </p:sp>
+      <p:sp>
+        <p:nvSpPr>
+          <p:cNvPr id="32" name="Rectangle 31">
+            <a:extLst>
+              <a:ext uri="{FF2B5EF4-FFF2-40B4-BE49-F238E27FC236}">
+                <a16:creationId xmlns:a16="http://schemas.microsoft.com/office/drawing/2014/main" id="{17953843-179C-45F6-B613-B7637671B7FF}"/>
+              </a:ext>
+            </a:extLst>
+          </p:cNvPr>
+          <p:cNvSpPr>
+            <a:spLocks noGrp="1"/>
+          </p:cNvSpPr>
+          <p:nvPr/>
+        </p:nvSpPr>
+        <p:spPr>
+          <a:xfrm>
+            <a:off x="4362450" y="3571875"/>
+            <a:ext cx="1714500" cy="228600"/>
+          </a:xfrm>
+          <a:prstGeom prst="rect">
+            <a:avLst/>
+          </a:prstGeom>
+          <a:noFill/>
+          <a:ln w="0">
+            <a:noFill/>
+            <a:prstDash val="solid"/>
+          </a:ln>
+        </p:spPr>
+        <p:txBody>
+          <a:bodyPr wrap="square" lIns="0" tIns="0" rIns="0" bIns="0" anchor="ctr">
+            <a:normAutofit/>
+          </a:bodyPr>
+          <a:lstStyle/>
+          <a:p>
+            <a:pPr marL="0" indent="0" algn="ctr">
+              <a:spcAft>
+                <a:spcPts val="0"/>
+              </a:spcAft>
+              <a:buNone/>
+              <a:defRPr sz="975" b="1">
+                <a:solidFill>
+                  <a:srgbClr val="087C72"/>
+                </a:solidFill>
+                <a:latin typeface="Aptos"/>
+                <a:ea typeface="Aptos"/>
+                <a:cs typeface="Aptos"/>
+              </a:defRPr>
+            </a:pPr>
+            <a:r>
+              <a:rPr sz="975" b="1" i="0">
+                <a:solidFill>
+                  <a:srgbClr val="087C72"/>
+                </a:solidFill>
+                <a:latin typeface="Aptos"/>
+                <a:ea typeface="Aptos"/>
+                <a:cs typeface="Aptos"/>
+              </a:rPr>
+              <a:t>REAL MISSION CONTROL</a:t>
+            </a:r>
+          </a:p>
+        </p:txBody>
+      </p:sp>
+      <p:sp>
+        <p:nvSpPr>
+          <p:cNvPr id="33" name="Rounded Rectangle 32">
+            <a:extLst>
+              <a:ext uri="{FF2B5EF4-FFF2-40B4-BE49-F238E27FC236}">
+                <a16:creationId xmlns:a16="http://schemas.microsoft.com/office/drawing/2014/main" id="{EEBAE474-9FED-4BF3-A4E5-AFD77D68A122}"/>
+              </a:ext>
+            </a:extLst>
+          </p:cNvPr>
+          <p:cNvSpPr>
+            <a:spLocks noGrp="1"/>
+          </p:cNvSpPr>
+          <p:nvPr/>
+        </p:nvSpPr>
+        <p:spPr>
+          <a:xfrm>
+            <a:off x="4267200" y="3981450"/>
+            <a:ext cx="6972300" cy="2152650"/>
+          </a:xfrm>
+          <a:prstGeom prst="roundRect">
+            <a:avLst>
+              <a:gd name="adj" fmla="val 2655"/>
+            </a:avLst>
+          </a:prstGeom>
+          <a:solidFill>
+            <a:srgbClr val="FFFFFF"/>
+          </a:solidFill>
+          <a:ln w="9525">
+            <a:solidFill>
+              <a:srgbClr val="D6E3DF"/>
+            </a:solidFill>
+            <a:prstDash val="solid"/>
+          </a:ln>
+        </p:spPr>
+        <p:txBody>
+          <a:bodyPr/>
+          <a:lstStyle/>
+          <a:p>
+            <a:endParaRPr lang="en-US"/>
+          </a:p>
+        </p:txBody>
+      </p:sp>
+      <p:pic>
+        <p:nvPicPr>
+          <p:cNvPr id="67" name="Picture 66"/>
+          <p:cNvPicPr>
+            <a:picLocks noChangeAspect="1"/>
+          </p:cNvPicPr>
+          <p:nvPr/>
+        </p:nvPicPr>
+        <p:blipFill>
+          <a:blip r:embed="rId3"/>
+          <a:srcRect t="32652" b="32652"/>
+          <a:stretch>
+            <a:fillRect/>
+          </a:stretch>
+        </p:blipFill>
+        <p:spPr>
+          <a:xfrm>
+            <a:off x="4286250" y="4000500"/>
+            <a:ext cx="6934200" cy="2114550"/>
+          </a:xfrm>
+          <a:prstGeom prst="roundRect">
+            <a:avLst>
+              <a:gd name="adj" fmla="val 2703"/>
+            </a:avLst>
+          </a:prstGeom>
+        </p:spPr>
+      </p:pic>
     </p:spTree>
     <p:extLst>
       <p:ext uri="{BB962C8B-B14F-4D97-AF65-F5344CB8AC3E}">
@@ -7579,6 +10334,14 @@
 <file path=ppt/slides/slide7.xml><?xml version="1.0" encoding="utf-8"?>
 <p:sld xmlns:a="http://schemas.openxmlformats.org/drawingml/2006/main" xmlns:r="http://schemas.openxmlformats.org/officeDocument/2006/relationships" xmlns:p="http://schemas.openxmlformats.org/presentationml/2006/main">
   <p:cSld>
+    <p:bg>
+      <p:bgPr>
+        <a:solidFill>
+          <a:srgbClr val="F8FBFA"/>
+        </a:solidFill>
+        <a:effectLst/>
+      </p:bgPr>
+    </p:bg>
     <p:spTree>
       <p:nvGrpSpPr>
         <p:cNvPr id="1" name=""/>
@@ -7609,21 +10372,42 @@
             <p:ph type="title"/>
           </p:nvPr>
         </p:nvSpPr>
-        <p:spPr/>
-        <p:txBody>
-          <a:bodyPr/>
-          <a:lstStyle/>
-          <a:p>
-            <a:pPr>
-              <a:buNone/>
-              <a:defRPr sz="3200">
-                <a:solidFill>
-                  <a:srgbClr val="1F6FEB"/>
-                </a:solidFill>
+        <p:spPr>
+          <a:xfrm>
+            <a:off x="609600" y="419100"/>
+            <a:ext cx="10934700" cy="781050"/>
+          </a:xfrm>
+        </p:spPr>
+        <p:txBody>
+          <a:bodyPr wrap="square" lIns="0" tIns="0" rIns="0" bIns="0" anchor="ctr">
+            <a:normAutofit/>
+          </a:bodyPr>
+          <a:lstStyle/>
+          <a:p>
+            <a:pPr marL="0" indent="0" algn="l">
+              <a:spcAft>
+                <a:spcPts val="0"/>
+              </a:spcAft>
+              <a:buNone/>
+              <a:defRPr sz="3600" b="1">
+                <a:solidFill>
+                  <a:srgbClr val="132925"/>
+                </a:solidFill>
+                <a:latin typeface="Aptos Display"/>
+                <a:ea typeface="Aptos Display"/>
+                <a:cs typeface="Aptos Display"/>
               </a:defRPr>
             </a:pPr>
             <a:r>
-              <a:t>Durable Mission Control</a:t>
+              <a:rPr sz="3600" b="1" i="0">
+                <a:solidFill>
+                  <a:srgbClr val="132925"/>
+                </a:solidFill>
+                <a:latin typeface="Aptos Display"/>
+                <a:ea typeface="Aptos Display"/>
+                <a:cs typeface="Aptos Display"/>
+              </a:rPr>
+              <a:t>Every event survives before it appears</a:t>
             </a:r>
           </a:p>
         </p:txBody>
@@ -7644,60 +10428,1258 @@
             <p:ph idx="1"/>
           </p:nvPr>
         </p:nvSpPr>
-        <p:spPr/>
-        <p:txBody>
-          <a:bodyPr wrap="square"/>
-          <a:lstStyle/>
-          <a:p>
-            <a:pPr>
-              <a:buNone/>
-            </a:pPr>
-            <a:r>
-              <a:rPr sz="1800">
-                <a:solidFill>
-                  <a:srgbClr val="222222"/>
-                </a:solidFill>
-              </a:rPr>
-              <a:t>A newly built durable-orchestration layer: SQLite-backed run and event repository, resumable Orchestrator.run(recovery=...) API, and a rebuilt Mission Control dashboard.</a:t>
-            </a:r>
-          </a:p>
-          <a:p>
-            <a:pPr>
-              <a:buNone/>
-            </a:pPr>
-            <a:r>
-              <a:rPr sz="1800">
-                <a:solidFill>
-                  <a:srgbClr val="222222"/>
-                </a:solidFill>
-              </a:rPr>
-              <a:t>Every completed wave persists a typed checkpoint (blackboard state + agent results) before moving on.</a:t>
-            </a:r>
-          </a:p>
-          <a:p>
-            <a:pPr>
-              <a:buNone/>
-            </a:pPr>
-            <a:r>
-              <a:rPr sz="1800">
-                <a:solidFill>
-                  <a:srgbClr val="222222"/>
-                </a:solidFill>
-              </a:rPr>
-              <a:t>A run that crashes mid-way resumes from its last wave checkpoint instead of restarting from agent one.</a:t>
-            </a:r>
-          </a:p>
-          <a:p>
-            <a:pPr>
-              <a:buNone/>
-            </a:pPr>
-            <a:r>
-              <a:rPr sz="1800">
-                <a:solidFill>
-                  <a:srgbClr val="222222"/>
-                </a:solidFill>
-              </a:rPr>
-              <a:t>The dashboard subscribes to a replayable SSE stream — refreshing or reconnecting resumes the same run rather than starting a new one.</a:t>
+        <p:spPr>
+          <a:xfrm>
+            <a:off x="685800" y="1504950"/>
+            <a:ext cx="3105150" cy="4724400"/>
+          </a:xfrm>
+        </p:spPr>
+        <p:txBody>
+          <a:bodyPr wrap="square" lIns="0" tIns="0" rIns="76200" bIns="0" anchor="t">
+            <a:normAutofit/>
+          </a:bodyPr>
+          <a:lstStyle/>
+          <a:p>
+            <a:pPr marL="0" indent="0" algn="l">
+              <a:spcAft>
+                <a:spcPts val="26"/>
+              </a:spcAft>
+              <a:buNone/>
+              <a:defRPr sz="1350" b="0">
+                <a:solidFill>
+                  <a:srgbClr val="132925"/>
+                </a:solidFill>
+                <a:latin typeface="Aptos"/>
+                <a:ea typeface="Aptos"/>
+                <a:cs typeface="Aptos"/>
+              </a:defRPr>
+            </a:pPr>
+            <a:r>
+              <a:rPr sz="1725" b="1" i="0">
+                <a:solidFill>
+                  <a:srgbClr val="132925"/>
+                </a:solidFill>
+                <a:latin typeface="Aptos"/>
+                <a:ea typeface="Aptos"/>
+                <a:cs typeface="Aptos"/>
+              </a:rPr>
+              <a:t>Durability is split by responsibility, not hidden in one database box.</a:t>
+            </a:r>
+          </a:p>
+          <a:p>
+            <a:pPr marL="0" indent="0" algn="l">
+              <a:spcAft>
+                <a:spcPts val="15"/>
+              </a:spcAft>
+              <a:buNone/>
+              <a:defRPr sz="1350" b="0">
+                <a:solidFill>
+                  <a:srgbClr val="132925"/>
+                </a:solidFill>
+                <a:latin typeface="Aptos"/>
+                <a:ea typeface="Aptos"/>
+                <a:cs typeface="Aptos"/>
+              </a:defRPr>
+            </a:pPr>
+            <a:r>
+              <a:rPr sz="1050" b="1" i="0">
+                <a:solidFill>
+                  <a:srgbClr val="087C72"/>
+                </a:solidFill>
+                <a:latin typeface="Aptos"/>
+                <a:ea typeface="Aptos"/>
+                <a:cs typeface="Aptos"/>
+              </a:rPr>
+              <a:t>IDEMPOTENT</a:t>
+            </a:r>
+            <a:r>
+              <a:rPr sz="1350" b="0" i="0">
+                <a:solidFill>
+                  <a:srgbClr val="132925"/>
+                </a:solidFill>
+                <a:latin typeface="Aptos"/>
+                <a:ea typeface="Aptos"/>
+                <a:cs typeface="Aptos"/>
+              </a:rPr>
+              <a:t>  Request UUIDs prevent duplicate runs.</a:t>
+            </a:r>
+          </a:p>
+          <a:p>
+            <a:pPr marL="0" indent="0" algn="l">
+              <a:spcAft>
+                <a:spcPts val="15"/>
+              </a:spcAft>
+              <a:buNone/>
+              <a:defRPr sz="1350" b="0">
+                <a:solidFill>
+                  <a:srgbClr val="132925"/>
+                </a:solidFill>
+                <a:latin typeface="Aptos"/>
+                <a:ea typeface="Aptos"/>
+                <a:cs typeface="Aptos"/>
+              </a:defRPr>
+            </a:pPr>
+            <a:r>
+              <a:rPr sz="1050" b="1" i="0">
+                <a:solidFill>
+                  <a:srgbClr val="087C72"/>
+                </a:solidFill>
+                <a:latin typeface="Aptos"/>
+                <a:ea typeface="Aptos"/>
+                <a:cs typeface="Aptos"/>
+              </a:rPr>
+              <a:t>ORDERED</a:t>
+            </a:r>
+            <a:r>
+              <a:rPr sz="1350" b="0" i="0">
+                <a:solidFill>
+                  <a:srgbClr val="132925"/>
+                </a:solidFill>
+                <a:latin typeface="Aptos"/>
+                <a:ea typeface="Aptos"/>
+                <a:cs typeface="Aptos"/>
+              </a:rPr>
+              <a:t>  Events persist before SSE publishes.</a:t>
+            </a:r>
+          </a:p>
+          <a:p>
+            <a:pPr marL="0" indent="0" algn="l">
+              <a:spcAft>
+                <a:spcPts val="15"/>
+              </a:spcAft>
+              <a:buNone/>
+              <a:defRPr sz="1350" b="0">
+                <a:solidFill>
+                  <a:srgbClr val="132925"/>
+                </a:solidFill>
+                <a:latin typeface="Aptos"/>
+                <a:ea typeface="Aptos"/>
+                <a:cs typeface="Aptos"/>
+              </a:defRPr>
+            </a:pPr>
+            <a:r>
+              <a:rPr sz="1050" b="1" i="0">
+                <a:solidFill>
+                  <a:srgbClr val="087C72"/>
+                </a:solidFill>
+                <a:latin typeface="Aptos"/>
+                <a:ea typeface="Aptos"/>
+                <a:cs typeface="Aptos"/>
+              </a:rPr>
+              <a:t>REPLAYABLE</a:t>
+            </a:r>
+            <a:r>
+              <a:rPr sz="1350" b="0" i="0">
+                <a:solidFill>
+                  <a:srgbClr val="132925"/>
+                </a:solidFill>
+                <a:latin typeface="Aptos"/>
+                <a:ea typeface="Aptos"/>
+                <a:cs typeface="Aptos"/>
+              </a:rPr>
+              <a:t>  Refresh resumes ordered history.</a:t>
+            </a:r>
+          </a:p>
+          <a:p>
+            <a:pPr marL="0" indent="0" algn="l">
+              <a:spcAft>
+                <a:spcPts val="15"/>
+              </a:spcAft>
+              <a:buNone/>
+              <a:defRPr sz="1350" b="0">
+                <a:solidFill>
+                  <a:srgbClr val="132925"/>
+                </a:solidFill>
+                <a:latin typeface="Aptos"/>
+                <a:ea typeface="Aptos"/>
+                <a:cs typeface="Aptos"/>
+              </a:defRPr>
+            </a:pPr>
+            <a:r>
+              <a:rPr sz="1050" b="1" i="0">
+                <a:solidFill>
+                  <a:srgbClr val="087C72"/>
+                </a:solidFill>
+                <a:latin typeface="Aptos"/>
+                <a:ea typeface="Aptos"/>
+                <a:cs typeface="Aptos"/>
+              </a:rPr>
+              <a:t>RESUMABLE</a:t>
+            </a:r>
+            <a:r>
+              <a:rPr sz="1350" b="0" i="0">
+                <a:solidFill>
+                  <a:srgbClr val="132925"/>
+                </a:solidFill>
+                <a:latin typeface="Aptos"/>
+                <a:ea typeface="Aptos"/>
+                <a:cs typeface="Aptos"/>
+              </a:rPr>
+              <a:t>  Typed wave checkpoints restart safely.</a:t>
+            </a:r>
+          </a:p>
+          <a:p>
+            <a:pPr marL="0" indent="0" algn="l">
+              <a:spcAft>
+                <a:spcPts val="15"/>
+              </a:spcAft>
+              <a:buNone/>
+              <a:defRPr sz="1350" b="0">
+                <a:solidFill>
+                  <a:srgbClr val="132925"/>
+                </a:solidFill>
+                <a:latin typeface="Aptos"/>
+                <a:ea typeface="Aptos"/>
+                <a:cs typeface="Aptos"/>
+              </a:defRPr>
+            </a:pPr>
+            <a:r>
+              <a:rPr sz="1050" b="1" i="0">
+                <a:solidFill>
+                  <a:srgbClr val="087C72"/>
+                </a:solidFill>
+                <a:latin typeface="Aptos"/>
+                <a:ea typeface="Aptos"/>
+                <a:cs typeface="Aptos"/>
+              </a:rPr>
+              <a:t>RECOVERED</a:t>
+            </a:r>
+            <a:r>
+              <a:rPr sz="1350" b="0" i="0">
+                <a:solidFill>
+                  <a:srgbClr val="132925"/>
+                </a:solidFill>
+                <a:latin typeface="Aptos"/>
+                <a:ea typeface="Aptos"/>
+                <a:cs typeface="Aptos"/>
+              </a:rPr>
+              <a:t>  Startup repairs non-terminal work.</a:t>
+            </a:r>
+          </a:p>
+        </p:txBody>
+      </p:sp>
+      <p:sp>
+        <p:nvSpPr>
+          <p:cNvPr id="4" name="Rounded Rectangle 3">
+            <a:extLst>
+              <a:ext uri="{FF2B5EF4-FFF2-40B4-BE49-F238E27FC236}">
+                <a16:creationId xmlns:a16="http://schemas.microsoft.com/office/drawing/2014/main" id="{926D0B11-8DB3-41CB-9F56-FD61FE522E43}"/>
+              </a:ext>
+            </a:extLst>
+          </p:cNvPr>
+          <p:cNvSpPr>
+            <a:spLocks noGrp="1"/>
+          </p:cNvSpPr>
+          <p:nvPr/>
+        </p:nvSpPr>
+        <p:spPr>
+          <a:xfrm>
+            <a:off x="4400550" y="1809750"/>
+            <a:ext cx="1257300" cy="552450"/>
+          </a:xfrm>
+          <a:prstGeom prst="roundRect">
+            <a:avLst>
+              <a:gd name="adj" fmla="val 10345"/>
+            </a:avLst>
+          </a:prstGeom>
+          <a:solidFill>
+            <a:srgbClr val="FFFFFF"/>
+          </a:solidFill>
+          <a:ln w="9525">
+            <a:solidFill>
+              <a:srgbClr val="087C72"/>
+            </a:solidFill>
+            <a:prstDash val="solid"/>
+          </a:ln>
+        </p:spPr>
+        <p:txBody>
+          <a:bodyPr wrap="square" lIns="57150" tIns="57150" rIns="57150" bIns="57150" anchor="ctr">
+            <a:normAutofit/>
+          </a:bodyPr>
+          <a:lstStyle/>
+          <a:p>
+            <a:pPr marL="0" indent="0" algn="ctr">
+              <a:spcAft>
+                <a:spcPts val="0"/>
+              </a:spcAft>
+              <a:buNone/>
+              <a:defRPr sz="1200" b="1">
+                <a:solidFill>
+                  <a:srgbClr val="132925"/>
+                </a:solidFill>
+                <a:latin typeface="Aptos"/>
+                <a:ea typeface="Aptos"/>
+                <a:cs typeface="Aptos"/>
+              </a:defRPr>
+            </a:pPr>
+            <a:r>
+              <a:rPr sz="1200" b="1" i="0">
+                <a:solidFill>
+                  <a:srgbClr val="132925"/>
+                </a:solidFill>
+                <a:latin typeface="Aptos"/>
+                <a:ea typeface="Aptos"/>
+                <a:cs typeface="Aptos"/>
+              </a:rPr>
+              <a:t>Intake API</a:t>
+            </a:r>
+          </a:p>
+        </p:txBody>
+      </p:sp>
+      <p:sp>
+        <p:nvSpPr>
+          <p:cNvPr id="5" name="Rounded Rectangle 4">
+            <a:extLst>
+              <a:ext uri="{FF2B5EF4-FFF2-40B4-BE49-F238E27FC236}">
+                <a16:creationId xmlns:a16="http://schemas.microsoft.com/office/drawing/2014/main" id="{75D6BDBC-8361-49D4-86B4-A907B184369B}"/>
+              </a:ext>
+            </a:extLst>
+          </p:cNvPr>
+          <p:cNvSpPr>
+            <a:spLocks noGrp="1"/>
+          </p:cNvSpPr>
+          <p:nvPr/>
+        </p:nvSpPr>
+        <p:spPr>
+          <a:xfrm>
+            <a:off x="6210300" y="1733550"/>
+            <a:ext cx="1352550" cy="704850"/>
+          </a:xfrm>
+          <a:prstGeom prst="roundRect">
+            <a:avLst>
+              <a:gd name="adj" fmla="val 8108"/>
+            </a:avLst>
+          </a:prstGeom>
+          <a:solidFill>
+            <a:srgbClr val="0B3D38"/>
+          </a:solidFill>
+          <a:ln w="9525">
+            <a:solidFill>
+              <a:srgbClr val="0B3D38"/>
+            </a:solidFill>
+            <a:prstDash val="solid"/>
+          </a:ln>
+        </p:spPr>
+        <p:txBody>
+          <a:bodyPr wrap="square" lIns="57150" tIns="57150" rIns="57150" bIns="57150" anchor="ctr">
+            <a:normAutofit/>
+          </a:bodyPr>
+          <a:lstStyle/>
+          <a:p>
+            <a:pPr marL="0" indent="0" algn="ctr">
+              <a:spcAft>
+                <a:spcPts val="0"/>
+              </a:spcAft>
+              <a:buNone/>
+              <a:defRPr sz="1200" b="1">
+                <a:solidFill>
+                  <a:srgbClr val="FFFFFF"/>
+                </a:solidFill>
+                <a:latin typeface="Aptos"/>
+                <a:ea typeface="Aptos"/>
+                <a:cs typeface="Aptos"/>
+              </a:defRPr>
+            </a:pPr>
+            <a:r>
+              <a:rPr sz="1200" b="1" i="0">
+                <a:solidFill>
+                  <a:srgbClr val="FFFFFF"/>
+                </a:solidFill>
+                <a:latin typeface="Aptos"/>
+                <a:ea typeface="Aptos"/>
+                <a:cs typeface="Aptos"/>
+              </a:rPr>
+              <a:t>Agent
+Orchestrator</a:t>
+            </a:r>
+          </a:p>
+        </p:txBody>
+      </p:sp>
+      <p:sp>
+        <p:nvSpPr>
+          <p:cNvPr id="6" name="Rounded Rectangle 5">
+            <a:extLst>
+              <a:ext uri="{FF2B5EF4-FFF2-40B4-BE49-F238E27FC236}">
+                <a16:creationId xmlns:a16="http://schemas.microsoft.com/office/drawing/2014/main" id="{2DC5CCE1-177D-45E5-BA48-28C71FFB0248}"/>
+              </a:ext>
+            </a:extLst>
+          </p:cNvPr>
+          <p:cNvSpPr>
+            <a:spLocks noGrp="1"/>
+          </p:cNvSpPr>
+          <p:nvPr/>
+        </p:nvSpPr>
+        <p:spPr>
+          <a:xfrm>
+            <a:off x="8115300" y="1733550"/>
+            <a:ext cx="1352550" cy="704850"/>
+          </a:xfrm>
+          <a:prstGeom prst="roundRect">
+            <a:avLst>
+              <a:gd name="adj" fmla="val 8108"/>
+            </a:avLst>
+          </a:prstGeom>
+          <a:solidFill>
+            <a:srgbClr val="FFFFFF"/>
+          </a:solidFill>
+          <a:ln w="9525">
+            <a:solidFill>
+              <a:srgbClr val="087C72"/>
+            </a:solidFill>
+            <a:prstDash val="solid"/>
+          </a:ln>
+        </p:spPr>
+        <p:txBody>
+          <a:bodyPr wrap="square" lIns="57150" tIns="57150" rIns="57150" bIns="57150" anchor="ctr">
+            <a:normAutofit/>
+          </a:bodyPr>
+          <a:lstStyle/>
+          <a:p>
+            <a:pPr marL="0" indent="0" algn="ctr">
+              <a:spcAft>
+                <a:spcPts val="0"/>
+              </a:spcAft>
+              <a:buNone/>
+              <a:defRPr sz="1200" b="1">
+                <a:solidFill>
+                  <a:srgbClr val="132925"/>
+                </a:solidFill>
+                <a:latin typeface="Aptos"/>
+                <a:ea typeface="Aptos"/>
+                <a:cs typeface="Aptos"/>
+              </a:defRPr>
+            </a:pPr>
+            <a:r>
+              <a:rPr sz="1200" b="1" i="0">
+                <a:solidFill>
+                  <a:srgbClr val="132925"/>
+                </a:solidFill>
+                <a:latin typeface="Aptos"/>
+                <a:ea typeface="Aptos"/>
+                <a:cs typeface="Aptos"/>
+              </a:rPr>
+              <a:t>Ordered
+SSE stream</a:t>
+            </a:r>
+          </a:p>
+        </p:txBody>
+      </p:sp>
+      <p:sp>
+        <p:nvSpPr>
+          <p:cNvPr id="7" name="Rounded Rectangle 6">
+            <a:extLst>
+              <a:ext uri="{FF2B5EF4-FFF2-40B4-BE49-F238E27FC236}">
+                <a16:creationId xmlns:a16="http://schemas.microsoft.com/office/drawing/2014/main" id="{BF40EC12-658B-4625-9587-CF4334D7441B}"/>
+              </a:ext>
+            </a:extLst>
+          </p:cNvPr>
+          <p:cNvSpPr>
+            <a:spLocks noGrp="1"/>
+          </p:cNvSpPr>
+          <p:nvPr/>
+        </p:nvSpPr>
+        <p:spPr>
+          <a:xfrm>
+            <a:off x="10020300" y="1733550"/>
+            <a:ext cx="1352550" cy="704850"/>
+          </a:xfrm>
+          <a:prstGeom prst="roundRect">
+            <a:avLst>
+              <a:gd name="adj" fmla="val 8108"/>
+            </a:avLst>
+          </a:prstGeom>
+          <a:solidFill>
+            <a:srgbClr val="FFFFFF"/>
+          </a:solidFill>
+          <a:ln w="9525">
+            <a:solidFill>
+              <a:srgbClr val="087C72"/>
+            </a:solidFill>
+            <a:prstDash val="solid"/>
+          </a:ln>
+        </p:spPr>
+        <p:txBody>
+          <a:bodyPr wrap="square" lIns="57150" tIns="57150" rIns="57150" bIns="57150" anchor="ctr">
+            <a:normAutofit/>
+          </a:bodyPr>
+          <a:lstStyle/>
+          <a:p>
+            <a:pPr marL="0" indent="0" algn="ctr">
+              <a:spcAft>
+                <a:spcPts val="0"/>
+              </a:spcAft>
+              <a:buNone/>
+              <a:defRPr sz="1200" b="1">
+                <a:solidFill>
+                  <a:srgbClr val="132925"/>
+                </a:solidFill>
+                <a:latin typeface="Aptos"/>
+                <a:ea typeface="Aptos"/>
+                <a:cs typeface="Aptos"/>
+              </a:defRPr>
+            </a:pPr>
+            <a:r>
+              <a:rPr sz="1200" b="1" i="0">
+                <a:solidFill>
+                  <a:srgbClr val="132925"/>
+                </a:solidFill>
+                <a:latin typeface="Aptos"/>
+                <a:ea typeface="Aptos"/>
+                <a:cs typeface="Aptos"/>
+              </a:rPr>
+              <a:t>Mission
+Control</a:t>
+            </a:r>
+          </a:p>
+        </p:txBody>
+      </p:sp>
+      <p:cxnSp>
+        <p:nvCxnSpPr>
+          <p:cNvPr id="28" name="Straight Arrow Connector 27"/>
+          <p:cNvCxnSpPr>
+            <a:stCxn id="4" idx="3"/>
+            <a:endCxn id="5" idx="1"/>
+          </p:cNvCxnSpPr>
+          <p:nvPr/>
+        </p:nvCxnSpPr>
+        <p:spPr>
+          <a:xfrm>
+            <a:off x="5657850" y="2085975"/>
+            <a:ext cx="552450" cy="0"/>
+          </a:xfrm>
+          <a:prstGeom prst="straightConnector1">
+            <a:avLst/>
+          </a:prstGeom>
+          <a:ln w="19050">
+            <a:solidFill>
+              <a:srgbClr val="D6E3DF"/>
+            </a:solidFill>
+            <a:prstDash val="solid"/>
+            <a:headEnd type="none" w="med" len="med"/>
+            <a:tailEnd type="arrow" w="sm" len="sm"/>
+          </a:ln>
+        </p:spPr>
+      </p:cxnSp>
+      <p:cxnSp>
+        <p:nvCxnSpPr>
+          <p:cNvPr id="29" name="Straight Arrow Connector 28"/>
+          <p:cNvCxnSpPr>
+            <a:stCxn id="5" idx="3"/>
+            <a:endCxn id="6" idx="1"/>
+          </p:cNvCxnSpPr>
+          <p:nvPr/>
+        </p:nvCxnSpPr>
+        <p:spPr>
+          <a:xfrm>
+            <a:off x="7562850" y="2085975"/>
+            <a:ext cx="552450" cy="0"/>
+          </a:xfrm>
+          <a:prstGeom prst="straightConnector1">
+            <a:avLst/>
+          </a:prstGeom>
+          <a:ln w="19050">
+            <a:solidFill>
+              <a:srgbClr val="D6E3DF"/>
+            </a:solidFill>
+            <a:prstDash val="solid"/>
+            <a:headEnd type="none" w="med" len="med"/>
+            <a:tailEnd type="arrow" w="sm" len="sm"/>
+          </a:ln>
+        </p:spPr>
+      </p:cxnSp>
+      <p:cxnSp>
+        <p:nvCxnSpPr>
+          <p:cNvPr id="30" name="Straight Arrow Connector 29"/>
+          <p:cNvCxnSpPr>
+            <a:stCxn id="6" idx="3"/>
+            <a:endCxn id="7" idx="1"/>
+          </p:cNvCxnSpPr>
+          <p:nvPr/>
+        </p:nvCxnSpPr>
+        <p:spPr>
+          <a:xfrm>
+            <a:off x="9467850" y="2085975"/>
+            <a:ext cx="552450" cy="0"/>
+          </a:xfrm>
+          <a:prstGeom prst="straightConnector1">
+            <a:avLst/>
+          </a:prstGeom>
+          <a:ln w="19050">
+            <a:solidFill>
+              <a:srgbClr val="D6E3DF"/>
+            </a:solidFill>
+            <a:prstDash val="solid"/>
+            <a:headEnd type="none" w="med" len="med"/>
+            <a:tailEnd type="arrow" w="sm" len="sm"/>
+          </a:ln>
+        </p:spPr>
+      </p:cxnSp>
+      <p:sp>
+        <p:nvSpPr>
+          <p:cNvPr id="11" name="Rectangle 10">
+            <a:extLst>
+              <a:ext uri="{FF2B5EF4-FFF2-40B4-BE49-F238E27FC236}">
+                <a16:creationId xmlns:a16="http://schemas.microsoft.com/office/drawing/2014/main" id="{A70AC137-056C-4AF0-9D66-21E634B4884F}"/>
+              </a:ext>
+            </a:extLst>
+          </p:cNvPr>
+          <p:cNvSpPr>
+            <a:spLocks noGrp="1"/>
+          </p:cNvSpPr>
+          <p:nvPr/>
+        </p:nvSpPr>
+        <p:spPr>
+          <a:xfrm>
+            <a:off x="7715250" y="1352550"/>
+            <a:ext cx="2152650" cy="247650"/>
+          </a:xfrm>
+          <a:prstGeom prst="rect">
+            <a:avLst/>
+          </a:prstGeom>
+          <a:noFill/>
+          <a:ln w="0">
+            <a:noFill/>
+            <a:prstDash val="solid"/>
+          </a:ln>
+        </p:spPr>
+        <p:txBody>
+          <a:bodyPr wrap="square" lIns="0" tIns="0" rIns="0" bIns="0" anchor="ctr">
+            <a:normAutofit/>
+          </a:bodyPr>
+          <a:lstStyle/>
+          <a:p>
+            <a:pPr marL="0" indent="0" algn="ctr">
+              <a:spcAft>
+                <a:spcPts val="0"/>
+              </a:spcAft>
+              <a:buNone/>
+              <a:defRPr sz="975" b="1">
+                <a:solidFill>
+                  <a:srgbClr val="087C72"/>
+                </a:solidFill>
+                <a:latin typeface="Aptos"/>
+                <a:ea typeface="Aptos"/>
+                <a:cs typeface="Aptos"/>
+              </a:defRPr>
+            </a:pPr>
+            <a:r>
+              <a:rPr sz="975" b="1" i="0">
+                <a:solidFill>
+                  <a:srgbClr val="087C72"/>
+                </a:solidFill>
+                <a:latin typeface="Aptos"/>
+                <a:ea typeface="Aptos"/>
+                <a:cs typeface="Aptos"/>
+              </a:rPr>
+              <a:t>PERSIST BEFORE PUBLISH</a:t>
+            </a:r>
+          </a:p>
+        </p:txBody>
+      </p:sp>
+      <p:sp>
+        <p:nvSpPr>
+          <p:cNvPr id="12" name="Rounded Rectangle 11">
+            <a:extLst>
+              <a:ext uri="{FF2B5EF4-FFF2-40B4-BE49-F238E27FC236}">
+                <a16:creationId xmlns:a16="http://schemas.microsoft.com/office/drawing/2014/main" id="{77156681-EB9F-49FE-9F27-4CAC03995782}"/>
+              </a:ext>
+            </a:extLst>
+          </p:cNvPr>
+          <p:cNvSpPr>
+            <a:spLocks noGrp="1"/>
+          </p:cNvSpPr>
+          <p:nvPr/>
+        </p:nvSpPr>
+        <p:spPr>
+          <a:xfrm>
+            <a:off x="4324350" y="3600450"/>
+            <a:ext cx="1600200" cy="1123950"/>
+          </a:xfrm>
+          <a:prstGeom prst="roundRect">
+            <a:avLst>
+              <a:gd name="adj" fmla="val 5085"/>
+            </a:avLst>
+          </a:prstGeom>
+          <a:solidFill>
+            <a:srgbClr val="FFFFFF"/>
+          </a:solidFill>
+          <a:ln w="19050">
+            <a:solidFill>
+              <a:srgbClr val="087C72"/>
+            </a:solidFill>
+            <a:prstDash val="solid"/>
+          </a:ln>
+        </p:spPr>
+        <p:txBody>
+          <a:bodyPr wrap="square" lIns="95250" tIns="95250" rIns="95250" bIns="95250" anchor="ctr">
+            <a:normAutofit/>
+          </a:bodyPr>
+          <a:lstStyle/>
+          <a:p>
+            <a:pPr marL="0" indent="0" algn="ctr">
+              <a:spcAft>
+                <a:spcPts val="10"/>
+              </a:spcAft>
+              <a:buNone/>
+              <a:defRPr sz="1125" b="0">
+                <a:solidFill>
+                  <a:srgbClr val="132925"/>
+                </a:solidFill>
+                <a:latin typeface="Aptos"/>
+                <a:ea typeface="Aptos"/>
+                <a:cs typeface="Aptos"/>
+              </a:defRPr>
+            </a:pPr>
+            <a:r>
+              <a:rPr sz="1350" b="1" i="0">
+                <a:solidFill>
+                  <a:srgbClr val="132925"/>
+                </a:solidFill>
+                <a:latin typeface="Aptos"/>
+                <a:ea typeface="Aptos"/>
+                <a:cs typeface="Aptos"/>
+              </a:rPr>
+              <a:t>Intake store</a:t>
+            </a:r>
+          </a:p>
+          <a:p>
+            <a:pPr marL="0" indent="0" algn="ctr">
+              <a:spcAft>
+                <a:spcPts val="0"/>
+              </a:spcAft>
+              <a:buNone/>
+              <a:defRPr sz="1125" b="0">
+                <a:solidFill>
+                  <a:srgbClr val="132925"/>
+                </a:solidFill>
+                <a:latin typeface="Aptos"/>
+                <a:ea typeface="Aptos"/>
+                <a:cs typeface="Aptos"/>
+              </a:defRPr>
+            </a:pPr>
+            <a:r>
+              <a:rPr sz="1125" b="0" i="0">
+                <a:solidFill>
+                  <a:srgbClr val="5B6F6A"/>
+                </a:solidFill>
+                <a:latin typeface="Aptos"/>
+                <a:ea typeface="Aptos"/>
+                <a:cs typeface="Aptos"/>
+              </a:rPr>
+              <a:t>Lifecycle + confirmed snapshots</a:t>
+            </a:r>
+          </a:p>
+        </p:txBody>
+      </p:sp>
+      <p:sp>
+        <p:nvSpPr>
+          <p:cNvPr id="13" name="Rounded Rectangle 12">
+            <a:extLst>
+              <a:ext uri="{FF2B5EF4-FFF2-40B4-BE49-F238E27FC236}">
+                <a16:creationId xmlns:a16="http://schemas.microsoft.com/office/drawing/2014/main" id="{074178AE-4EDB-4CCF-B658-3DEA4F6C394B}"/>
+              </a:ext>
+            </a:extLst>
+          </p:cNvPr>
+          <p:cNvSpPr>
+            <a:spLocks noGrp="1"/>
+          </p:cNvSpPr>
+          <p:nvPr/>
+        </p:nvSpPr>
+        <p:spPr>
+          <a:xfrm>
+            <a:off x="6096000" y="3600450"/>
+            <a:ext cx="1600200" cy="1123950"/>
+          </a:xfrm>
+          <a:prstGeom prst="roundRect">
+            <a:avLst>
+              <a:gd name="adj" fmla="val 5085"/>
+            </a:avLst>
+          </a:prstGeom>
+          <a:solidFill>
+            <a:srgbClr val="FFFFFF"/>
+          </a:solidFill>
+          <a:ln w="19050">
+            <a:solidFill>
+              <a:srgbClr val="C47A00"/>
+            </a:solidFill>
+            <a:prstDash val="solid"/>
+          </a:ln>
+        </p:spPr>
+        <p:txBody>
+          <a:bodyPr wrap="square" lIns="95250" tIns="95250" rIns="95250" bIns="95250" anchor="ctr">
+            <a:normAutofit/>
+          </a:bodyPr>
+          <a:lstStyle/>
+          <a:p>
+            <a:pPr marL="0" indent="0" algn="ctr">
+              <a:spcAft>
+                <a:spcPts val="10"/>
+              </a:spcAft>
+              <a:buNone/>
+              <a:defRPr sz="1125" b="0">
+                <a:solidFill>
+                  <a:srgbClr val="132925"/>
+                </a:solidFill>
+                <a:latin typeface="Aptos"/>
+                <a:ea typeface="Aptos"/>
+                <a:cs typeface="Aptos"/>
+              </a:defRPr>
+            </a:pPr>
+            <a:r>
+              <a:rPr sz="1350" b="1" i="0">
+                <a:solidFill>
+                  <a:srgbClr val="132925"/>
+                </a:solidFill>
+                <a:latin typeface="Aptos"/>
+                <a:ea typeface="Aptos"/>
+                <a:cs typeface="Aptos"/>
+              </a:rPr>
+              <a:t>Artifact files</a:t>
+            </a:r>
+          </a:p>
+          <a:p>
+            <a:pPr marL="0" indent="0" algn="ctr">
+              <a:spcAft>
+                <a:spcPts val="0"/>
+              </a:spcAft>
+              <a:buNone/>
+              <a:defRPr sz="1125" b="0">
+                <a:solidFill>
+                  <a:srgbClr val="132925"/>
+                </a:solidFill>
+                <a:latin typeface="Aptos"/>
+                <a:ea typeface="Aptos"/>
+                <a:cs typeface="Aptos"/>
+              </a:defRPr>
+            </a:pPr>
+            <a:r>
+              <a:rPr sz="1125" b="0" i="0">
+                <a:solidFill>
+                  <a:srgbClr val="5B6F6A"/>
+                </a:solidFill>
+                <a:latin typeface="Aptos"/>
+                <a:ea typeface="Aptos"/>
+                <a:cs typeface="Aptos"/>
+              </a:rPr>
+              <a:t>Immutable uploaded evidence</a:t>
+            </a:r>
+          </a:p>
+        </p:txBody>
+      </p:sp>
+      <p:sp>
+        <p:nvSpPr>
+          <p:cNvPr id="14" name="Rounded Rectangle 13">
+            <a:extLst>
+              <a:ext uri="{FF2B5EF4-FFF2-40B4-BE49-F238E27FC236}">
+                <a16:creationId xmlns:a16="http://schemas.microsoft.com/office/drawing/2014/main" id="{03FA926D-8DF7-4C91-894D-6ACB2275098C}"/>
+              </a:ext>
+            </a:extLst>
+          </p:cNvPr>
+          <p:cNvSpPr>
+            <a:spLocks noGrp="1"/>
+          </p:cNvSpPr>
+          <p:nvPr/>
+        </p:nvSpPr>
+        <p:spPr>
+          <a:xfrm>
+            <a:off x="7867650" y="3600450"/>
+            <a:ext cx="1600200" cy="1123950"/>
+          </a:xfrm>
+          <a:prstGeom prst="roundRect">
+            <a:avLst>
+              <a:gd name="adj" fmla="val 5085"/>
+            </a:avLst>
+          </a:prstGeom>
+          <a:solidFill>
+            <a:srgbClr val="FFFFFF"/>
+          </a:solidFill>
+          <a:ln w="19050">
+            <a:solidFill>
+              <a:srgbClr val="087C72"/>
+            </a:solidFill>
+            <a:prstDash val="solid"/>
+          </a:ln>
+        </p:spPr>
+        <p:txBody>
+          <a:bodyPr wrap="square" lIns="95250" tIns="95250" rIns="95250" bIns="95250" anchor="ctr">
+            <a:normAutofit/>
+          </a:bodyPr>
+          <a:lstStyle/>
+          <a:p>
+            <a:pPr marL="0" indent="0" algn="ctr">
+              <a:spcAft>
+                <a:spcPts val="10"/>
+              </a:spcAft>
+              <a:buNone/>
+              <a:defRPr sz="1125" b="0">
+                <a:solidFill>
+                  <a:srgbClr val="132925"/>
+                </a:solidFill>
+                <a:latin typeface="Aptos"/>
+                <a:ea typeface="Aptos"/>
+                <a:cs typeface="Aptos"/>
+              </a:defRPr>
+            </a:pPr>
+            <a:r>
+              <a:rPr sz="1350" b="1" i="0">
+                <a:solidFill>
+                  <a:srgbClr val="132925"/>
+                </a:solidFill>
+                <a:latin typeface="Aptos"/>
+                <a:ea typeface="Aptos"/>
+                <a:cs typeface="Aptos"/>
+              </a:rPr>
+              <a:t>Run + event store</a:t>
+            </a:r>
+          </a:p>
+          <a:p>
+            <a:pPr marL="0" indent="0" algn="ctr">
+              <a:spcAft>
+                <a:spcPts val="0"/>
+              </a:spcAft>
+              <a:buNone/>
+              <a:defRPr sz="1125" b="0">
+                <a:solidFill>
+                  <a:srgbClr val="132925"/>
+                </a:solidFill>
+                <a:latin typeface="Aptos"/>
+                <a:ea typeface="Aptos"/>
+                <a:cs typeface="Aptos"/>
+              </a:defRPr>
+            </a:pPr>
+            <a:r>
+              <a:rPr sz="1125" b="0" i="0">
+                <a:solidFill>
+                  <a:srgbClr val="5B6F6A"/>
+                </a:solidFill>
+                <a:latin typeface="Aptos"/>
+                <a:ea typeface="Aptos"/>
+                <a:cs typeface="Aptos"/>
+              </a:rPr>
+              <a:t>Events + wave checkpoints</a:t>
+            </a:r>
+          </a:p>
+        </p:txBody>
+      </p:sp>
+      <p:sp>
+        <p:nvSpPr>
+          <p:cNvPr id="15" name="Rounded Rectangle 14">
+            <a:extLst>
+              <a:ext uri="{FF2B5EF4-FFF2-40B4-BE49-F238E27FC236}">
+                <a16:creationId xmlns:a16="http://schemas.microsoft.com/office/drawing/2014/main" id="{08E7F768-7919-4B4D-BF81-AD98246DAF23}"/>
+              </a:ext>
+            </a:extLst>
+          </p:cNvPr>
+          <p:cNvSpPr>
+            <a:spLocks noGrp="1"/>
+          </p:cNvSpPr>
+          <p:nvPr/>
+        </p:nvSpPr>
+        <p:spPr>
+          <a:xfrm>
+            <a:off x="9639300" y="3600450"/>
+            <a:ext cx="1600200" cy="1123950"/>
+          </a:xfrm>
+          <a:prstGeom prst="roundRect">
+            <a:avLst>
+              <a:gd name="adj" fmla="val 5085"/>
+            </a:avLst>
+          </a:prstGeom>
+          <a:solidFill>
+            <a:srgbClr val="FFFFFF"/>
+          </a:solidFill>
+          <a:ln w="19050">
+            <a:solidFill>
+              <a:srgbClr val="B42318"/>
+            </a:solidFill>
+            <a:prstDash val="solid"/>
+          </a:ln>
+        </p:spPr>
+        <p:txBody>
+          <a:bodyPr wrap="square" lIns="95250" tIns="95250" rIns="95250" bIns="95250" anchor="ctr">
+            <a:normAutofit/>
+          </a:bodyPr>
+          <a:lstStyle/>
+          <a:p>
+            <a:pPr marL="0" indent="0" algn="ctr">
+              <a:spcAft>
+                <a:spcPts val="10"/>
+              </a:spcAft>
+              <a:buNone/>
+              <a:defRPr sz="1125" b="0">
+                <a:solidFill>
+                  <a:srgbClr val="132925"/>
+                </a:solidFill>
+                <a:latin typeface="Aptos"/>
+                <a:ea typeface="Aptos"/>
+                <a:cs typeface="Aptos"/>
+              </a:defRPr>
+            </a:pPr>
+            <a:r>
+              <a:rPr sz="1350" b="1" i="0">
+                <a:solidFill>
+                  <a:srgbClr val="132925"/>
+                </a:solidFill>
+                <a:latin typeface="Aptos"/>
+                <a:ea typeface="Aptos"/>
+                <a:cs typeface="Aptos"/>
+              </a:rPr>
+              <a:t>Memory + review</a:t>
+            </a:r>
+          </a:p>
+          <a:p>
+            <a:pPr marL="0" indent="0" algn="ctr">
+              <a:spcAft>
+                <a:spcPts val="0"/>
+              </a:spcAft>
+              <a:buNone/>
+              <a:defRPr sz="1125" b="0">
+                <a:solidFill>
+                  <a:srgbClr val="132925"/>
+                </a:solidFill>
+                <a:latin typeface="Aptos"/>
+                <a:ea typeface="Aptos"/>
+                <a:cs typeface="Aptos"/>
+              </a:defRPr>
+            </a:pPr>
+            <a:r>
+              <a:rPr sz="1125" b="0" i="0">
+                <a:solidFill>
+                  <a:srgbClr val="5B6F6A"/>
+                </a:solidFill>
+                <a:latin typeface="Aptos"/>
+                <a:ea typeface="Aptos"/>
+                <a:cs typeface="Aptos"/>
+              </a:rPr>
+              <a:t>Decision and reviewer ledgers</a:t>
+            </a:r>
+          </a:p>
+        </p:txBody>
+      </p:sp>
+      <p:cxnSp>
+        <p:nvCxnSpPr>
+          <p:cNvPr id="36" name="Elbow Connector 35"/>
+          <p:cNvCxnSpPr>
+            <a:stCxn id="4" idx="2"/>
+            <a:endCxn id="12" idx="0"/>
+          </p:cNvCxnSpPr>
+          <p:nvPr/>
+        </p:nvCxnSpPr>
+        <p:spPr>
+          <a:xfrm>
+            <a:off x="5029200" y="2362200"/>
+            <a:ext cx="95250" cy="1238250"/>
+          </a:xfrm>
+          <a:prstGeom prst="bentConnector4">
+            <a:avLst>
+              <a:gd name="adj1" fmla="val 0"/>
+              <a:gd name="adj2" fmla="val 50000"/>
+            </a:avLst>
+          </a:prstGeom>
+          <a:ln w="19050">
+            <a:solidFill>
+              <a:srgbClr val="D6E3DF"/>
+            </a:solidFill>
+            <a:prstDash val="solid"/>
+            <a:headEnd type="none" w="med" len="med"/>
+            <a:tailEnd type="none" w="med" len="med"/>
+          </a:ln>
+        </p:spPr>
+      </p:cxnSp>
+      <p:cxnSp>
+        <p:nvCxnSpPr>
+          <p:cNvPr id="37" name="Elbow Connector 36"/>
+          <p:cNvCxnSpPr>
+            <a:stCxn id="4" idx="2"/>
+            <a:endCxn id="13" idx="0"/>
+          </p:cNvCxnSpPr>
+          <p:nvPr/>
+        </p:nvCxnSpPr>
+        <p:spPr>
+          <a:xfrm>
+            <a:off x="5029200" y="2362200"/>
+            <a:ext cx="1866900" cy="1238250"/>
+          </a:xfrm>
+          <a:prstGeom prst="bentConnector4">
+            <a:avLst>
+              <a:gd name="adj1" fmla="val 0"/>
+              <a:gd name="adj2" fmla="val 50000"/>
+            </a:avLst>
+          </a:prstGeom>
+          <a:ln w="19050">
+            <a:solidFill>
+              <a:srgbClr val="D7B56D"/>
+            </a:solidFill>
+            <a:prstDash val="solid"/>
+            <a:headEnd type="none" w="med" len="med"/>
+            <a:tailEnd type="none" w="med" len="med"/>
+          </a:ln>
+        </p:spPr>
+      </p:cxnSp>
+      <p:cxnSp>
+        <p:nvCxnSpPr>
+          <p:cNvPr id="38" name="Elbow Connector 37"/>
+          <p:cNvCxnSpPr>
+            <a:stCxn id="5" idx="2"/>
+            <a:endCxn id="14" idx="0"/>
+          </p:cNvCxnSpPr>
+          <p:nvPr/>
+        </p:nvCxnSpPr>
+        <p:spPr>
+          <a:xfrm>
+            <a:off x="6886575" y="2438400"/>
+            <a:ext cx="1781175" cy="1162050"/>
+          </a:xfrm>
+          <a:prstGeom prst="bentConnector4">
+            <a:avLst>
+              <a:gd name="adj1" fmla="val 0"/>
+              <a:gd name="adj2" fmla="val 50000"/>
+            </a:avLst>
+          </a:prstGeom>
+          <a:ln w="19050">
+            <a:solidFill>
+              <a:srgbClr val="D6E3DF"/>
+            </a:solidFill>
+            <a:prstDash val="solid"/>
+            <a:headEnd type="none" w="med" len="med"/>
+            <a:tailEnd type="none" w="med" len="med"/>
+          </a:ln>
+        </p:spPr>
+      </p:cxnSp>
+      <p:cxnSp>
+        <p:nvCxnSpPr>
+          <p:cNvPr id="39" name="Elbow Connector 38"/>
+          <p:cNvCxnSpPr>
+            <a:stCxn id="5" idx="2"/>
+            <a:endCxn id="15" idx="0"/>
+          </p:cNvCxnSpPr>
+          <p:nvPr/>
+        </p:nvCxnSpPr>
+        <p:spPr>
+          <a:xfrm>
+            <a:off x="6886575" y="2438400"/>
+            <a:ext cx="3552825" cy="1162050"/>
+          </a:xfrm>
+          <a:prstGeom prst="bentConnector4">
+            <a:avLst>
+              <a:gd name="adj1" fmla="val 0"/>
+              <a:gd name="adj2" fmla="val 50000"/>
+            </a:avLst>
+          </a:prstGeom>
+          <a:ln w="19050">
+            <a:solidFill>
+              <a:srgbClr val="D9A39E"/>
+            </a:solidFill>
+            <a:prstDash val="solid"/>
+            <a:headEnd type="none" w="med" len="med"/>
+            <a:tailEnd type="none" w="med" len="med"/>
+          </a:ln>
+        </p:spPr>
+      </p:cxnSp>
+      <p:sp>
+        <p:nvSpPr>
+          <p:cNvPr id="20" name="Rounded Rectangle 19">
+            <a:extLst>
+              <a:ext uri="{FF2B5EF4-FFF2-40B4-BE49-F238E27FC236}">
+                <a16:creationId xmlns:a16="http://schemas.microsoft.com/office/drawing/2014/main" id="{45AFE64D-26AC-4552-9D2E-942A2126A0C8}"/>
+              </a:ext>
+            </a:extLst>
+          </p:cNvPr>
+          <p:cNvSpPr>
+            <a:spLocks noGrp="1"/>
+          </p:cNvSpPr>
+          <p:nvPr/>
+        </p:nvSpPr>
+        <p:spPr>
+          <a:xfrm>
+            <a:off x="4324350" y="5105400"/>
+            <a:ext cx="6915150" cy="704850"/>
+          </a:xfrm>
+          <a:prstGeom prst="roundRect">
+            <a:avLst>
+              <a:gd name="adj" fmla="val 8108"/>
+            </a:avLst>
+          </a:prstGeom>
+          <a:solidFill>
+            <a:srgbClr val="FFF3D6"/>
+          </a:solidFill>
+          <a:ln w="9525">
+            <a:solidFill>
+              <a:srgbClr val="EACB88"/>
+            </a:solidFill>
+            <a:prstDash val="solid"/>
+          </a:ln>
+        </p:spPr>
+      </p:sp>
+      <p:sp>
+        <p:nvSpPr>
+          <p:cNvPr id="21" name="Rectangle 20">
+            <a:extLst>
+              <a:ext uri="{FF2B5EF4-FFF2-40B4-BE49-F238E27FC236}">
+                <a16:creationId xmlns:a16="http://schemas.microsoft.com/office/drawing/2014/main" id="{2E893F84-4BFD-46E4-84E4-1F7E4BEF04CE}"/>
+              </a:ext>
+            </a:extLst>
+          </p:cNvPr>
+          <p:cNvSpPr>
+            <a:spLocks noGrp="1"/>
+          </p:cNvSpPr>
+          <p:nvPr/>
+        </p:nvSpPr>
+        <p:spPr>
+          <a:xfrm>
+            <a:off x="4552950" y="5257800"/>
+            <a:ext cx="6457950" cy="400050"/>
+          </a:xfrm>
+          <a:prstGeom prst="rect">
+            <a:avLst/>
+          </a:prstGeom>
+          <a:noFill/>
+          <a:ln w="0">
+            <a:noFill/>
+            <a:prstDash val="solid"/>
+          </a:ln>
+        </p:spPr>
+        <p:txBody>
+          <a:bodyPr wrap="square" lIns="0" tIns="0" rIns="0" bIns="0" anchor="ctr">
+            <a:normAutofit fontScale="94595"/>
+          </a:bodyPr>
+          <a:lstStyle/>
+          <a:p>
+            <a:pPr marL="0" indent="0" algn="l">
+              <a:spcAft>
+                <a:spcPts val="0"/>
+              </a:spcAft>
+              <a:buNone/>
+              <a:defRPr sz="1200" b="0">
+                <a:solidFill>
+                  <a:srgbClr val="132925"/>
+                </a:solidFill>
+                <a:latin typeface="Aptos"/>
+                <a:ea typeface="Aptos"/>
+                <a:cs typeface="Aptos"/>
+              </a:defRPr>
+            </a:pPr>
+            <a:r>
+              <a:rPr sz="1575" b="1" i="0">
+                <a:solidFill>
+                  <a:srgbClr val="132925"/>
+                </a:solidFill>
+                <a:latin typeface="Aptos"/>
+                <a:ea typeface="Aptos"/>
+                <a:cs typeface="Aptos"/>
+              </a:rPr>
+              <a:t>Current SQLite lifecycle: one API replica</a:t>
+            </a:r>
+            <a:r>
+              <a:rPr sz="1200" b="0" i="0">
+                <a:solidFill>
+                  <a:srgbClr val="5B6F6A"/>
+                </a:solidFill>
+                <a:latin typeface="Aptos"/>
+                <a:ea typeface="Aptos"/>
+                <a:cs typeface="Aptos"/>
+              </a:rPr>
+              <a:t>   Honest scope today; repositories preserve a clean path to distributed storage.</a:t>
             </a:r>
           </a:p>
         </p:txBody>

</xml_diff>